<commit_message>
Add a three model comparison across the same five tasks
</commit_message>
<xml_diff>
--- a/deck/agentic-erp-study.pptx
+++ b/deck/agentic-erp-study.pptx
@@ -15,6 +15,7 @@
     <p:sldId id="263" r:id="rId14"/>
     <p:sldId id="264" r:id="rId15"/>
     <p:sldId id="265" r:id="rId16"/>
+    <p:sldId id="266" r:id="rId17"/>
   </p:sldIdLst>
   <p:sldSz cx="12191695" cy="6858000" type="screen4x3"/>
   <p:notesSz cx="6858000" cy="9144000"/>
@@ -3416,7 +3417,7 @@
                 </a:solidFill>
                 <a:latin typeface="Helvetica Neue"/>
               </a:rPr>
-              <a:t>WHAT THIS MEANS</a:t>
+              <a:t>FINDING 4</a:t>
             </a:r>
           </a:p>
         </p:txBody>
@@ -3458,7 +3459,7 @@
                 </a:solidFill>
                 <a:latin typeface="Georgia"/>
               </a:rPr>
-              <a:t>Three implications, for three audiences</a:t>
+              <a:t>Error messages are the agent's documentation</a:t>
             </a:r>
           </a:p>
         </p:txBody>
@@ -3507,8 +3508,8 @@
         </p:nvSpPr>
         <p:spPr>
           <a:xfrm>
-            <a:off x="640080" y="1920240"/>
-            <a:ext cx="640080" cy="548640"/>
+            <a:off x="640080" y="1828800"/>
+            <a:ext cx="10881360" cy="640080"/>
           </a:xfrm>
           <a:prstGeom prst="rect">
             <a:avLst/>
@@ -3523,446 +3524,38 @@
           <a:p>
             <a:pPr algn="l">
               <a:lnSpc>
-                <a:spcPct val="100000"/>
-              </a:lnSpc>
-              <a:spcAft>
-                <a:spcPts val="0"/>
-              </a:spcAft>
-            </a:pPr>
-            <a:r>
-              <a:rPr sz="2600" b="1" i="0">
-                <a:solidFill>
-                  <a:srgbClr val="0E6B6B"/>
-                </a:solidFill>
-                <a:latin typeface="Georgia"/>
-              </a:rPr>
-              <a:t>1</a:t>
-            </a:r>
-          </a:p>
-        </p:txBody>
-      </p:sp>
-      <p:sp>
-        <p:nvSpPr>
-          <p:cNvPr id="6" name="TextBox 5"/>
-          <p:cNvSpPr txBox="1"/>
-          <p:nvPr/>
-        </p:nvSpPr>
-        <p:spPr>
-          <a:xfrm>
-            <a:off x="1417320" y="1938528"/>
-            <a:ext cx="2377440" cy="822960"/>
-          </a:xfrm>
-          <a:prstGeom prst="rect">
-            <a:avLst/>
-          </a:prstGeom>
-          <a:noFill/>
-        </p:spPr>
-        <p:txBody>
-          <a:bodyPr wrap="square" anchor="t" lIns="0" rIns="0" tIns="0" bIns="0">
-            <a:spAutoFit/>
-          </a:bodyPr>
-          <a:lstStyle/>
-          <a:p>
-            <a:pPr algn="l">
-              <a:lnSpc>
-                <a:spcPct val="115000"/>
-              </a:lnSpc>
-              <a:spcAft>
-                <a:spcPts val="0"/>
-              </a:spcAft>
-            </a:pPr>
-            <a:r>
-              <a:rPr sz="1550" b="1" i="0">
+                <a:spcPct val="130000"/>
+              </a:lnSpc>
+              <a:spcAft>
+                <a:spcPts val="0"/>
+              </a:spcAft>
+            </a:pPr>
+            <a:r>
+              <a:rPr sz="1700" b="0" i="0">
                 <a:solidFill>
                   <a:srgbClr val="0B142A"/>
                 </a:solidFill>
                 <a:latin typeface="Helvetica Neue"/>
               </a:rPr>
-              <a:t>Agent builders</a:t>
-            </a:r>
-          </a:p>
-        </p:txBody>
-      </p:sp>
-      <p:sp>
-        <p:nvSpPr>
-          <p:cNvPr id="7" name="TextBox 6"/>
-          <p:cNvSpPr txBox="1"/>
-          <p:nvPr/>
-        </p:nvSpPr>
-        <p:spPr>
-          <a:xfrm>
-            <a:off x="3931920" y="1920240"/>
-            <a:ext cx="7680960" cy="1005840"/>
-          </a:xfrm>
-          <a:prstGeom prst="rect">
-            <a:avLst/>
-          </a:prstGeom>
-          <a:noFill/>
-        </p:spPr>
-        <p:txBody>
-          <a:bodyPr wrap="square" anchor="t" lIns="0" rIns="0" tIns="0" bIns="0">
-            <a:spAutoFit/>
-          </a:bodyPr>
-          <a:lstStyle/>
-          <a:p>
-            <a:pPr algn="l">
-              <a:lnSpc>
-                <a:spcPct val="130000"/>
-              </a:lnSpc>
-              <a:spcAft>
-                <a:spcPts val="0"/>
-              </a:spcAft>
-            </a:pPr>
-            <a:r>
-              <a:rPr sz="1450" b="0" i="0">
-                <a:solidFill>
-                  <a:srgbClr val="0B142A"/>
-                </a:solidFill>
-                <a:latin typeface="Helvetica Neue"/>
-              </a:rPr>
-              <a:t>Budget for the discovery problem. Agents will need curated tool definitions or metadata access, not raw OData endpoints and optimism.</a:t>
-            </a:r>
-          </a:p>
-        </p:txBody>
-      </p:sp>
-      <p:cxnSp>
-        <p:nvCxnSpPr>
-          <p:cNvPr id="8" name="Connector 7"/>
-          <p:cNvCxnSpPr/>
-          <p:nvPr/>
-        </p:nvCxnSpPr>
-        <p:spPr>
-          <a:xfrm>
-            <a:off x="640080" y="3017520"/>
-            <a:ext cx="10911535" cy="0"/>
-          </a:xfrm>
-          <a:prstGeom prst="line">
-            <a:avLst/>
-          </a:prstGeom>
-          <a:ln w="7620">
-            <a:solidFill>
-              <a:srgbClr val="DDE1E6"/>
-            </a:solidFill>
-          </a:ln>
-          <a:effectLst/>
-        </p:spPr>
-        <p:style>
-          <a:lnRef idx="2">
-            <a:schemeClr val="accent1"/>
-          </a:lnRef>
-          <a:fillRef idx="0">
-            <a:schemeClr val="accent1"/>
-          </a:fillRef>
-          <a:effectRef idx="1">
-            <a:schemeClr val="accent1"/>
-          </a:effectRef>
-          <a:fontRef idx="minor">
-            <a:schemeClr val="tx1"/>
-          </a:fontRef>
-        </p:style>
-      </p:cxnSp>
-      <p:sp>
-        <p:nvSpPr>
-          <p:cNvPr id="9" name="TextBox 8"/>
-          <p:cNvSpPr txBox="1"/>
-          <p:nvPr/>
-        </p:nvSpPr>
-        <p:spPr>
-          <a:xfrm>
-            <a:off x="640080" y="3154680"/>
-            <a:ext cx="640080" cy="548640"/>
-          </a:xfrm>
-          <a:prstGeom prst="rect">
-            <a:avLst/>
-          </a:prstGeom>
-          <a:noFill/>
-        </p:spPr>
-        <p:txBody>
-          <a:bodyPr wrap="square" anchor="t" lIns="0" rIns="0" tIns="0" bIns="0">
-            <a:spAutoFit/>
-          </a:bodyPr>
-          <a:lstStyle/>
-          <a:p>
-            <a:pPr algn="l">
-              <a:lnSpc>
-                <a:spcPct val="100000"/>
-              </a:lnSpc>
-              <a:spcAft>
-                <a:spcPts val="0"/>
-              </a:spcAft>
-            </a:pPr>
-            <a:r>
-              <a:rPr sz="2600" b="1" i="0">
-                <a:solidFill>
-                  <a:srgbClr val="0E6B6B"/>
-                </a:solidFill>
-                <a:latin typeface="Georgia"/>
-              </a:rPr>
-              <a:t>2</a:t>
-            </a:r>
-          </a:p>
-        </p:txBody>
-      </p:sp>
-      <p:sp>
-        <p:nvSpPr>
-          <p:cNvPr id="10" name="TextBox 9"/>
-          <p:cNvSpPr txBox="1"/>
-          <p:nvPr/>
-        </p:nvSpPr>
-        <p:spPr>
-          <a:xfrm>
-            <a:off x="1417320" y="3172968"/>
-            <a:ext cx="2377440" cy="822960"/>
-          </a:xfrm>
-          <a:prstGeom prst="rect">
-            <a:avLst/>
-          </a:prstGeom>
-          <a:noFill/>
-        </p:spPr>
-        <p:txBody>
-          <a:bodyPr wrap="square" anchor="t" lIns="0" rIns="0" tIns="0" bIns="0">
-            <a:spAutoFit/>
-          </a:bodyPr>
-          <a:lstStyle/>
-          <a:p>
-            <a:pPr algn="l">
-              <a:lnSpc>
-                <a:spcPct val="115000"/>
-              </a:lnSpc>
-              <a:spcAft>
-                <a:spcPts val="0"/>
-              </a:spcAft>
-            </a:pPr>
-            <a:r>
-              <a:rPr sz="1550" b="1" i="0">
-                <a:solidFill>
-                  <a:srgbClr val="0B142A"/>
-                </a:solidFill>
-                <a:latin typeface="Helvetica Neue"/>
-              </a:rPr>
-              <a:t>Buyers</a:t>
-            </a:r>
-          </a:p>
-        </p:txBody>
-      </p:sp>
-      <p:sp>
-        <p:nvSpPr>
-          <p:cNvPr id="11" name="TextBox 10"/>
-          <p:cNvSpPr txBox="1"/>
-          <p:nvPr/>
-        </p:nvSpPr>
-        <p:spPr>
-          <a:xfrm>
-            <a:off x="3931920" y="3154680"/>
-            <a:ext cx="7680960" cy="1005840"/>
-          </a:xfrm>
-          <a:prstGeom prst="rect">
-            <a:avLst/>
-          </a:prstGeom>
-          <a:noFill/>
-        </p:spPr>
-        <p:txBody>
-          <a:bodyPr wrap="square" anchor="t" lIns="0" rIns="0" tIns="0" bIns="0">
-            <a:spAutoFit/>
-          </a:bodyPr>
-          <a:lstStyle/>
-          <a:p>
-            <a:pPr algn="l">
-              <a:lnSpc>
-                <a:spcPct val="130000"/>
-              </a:lnSpc>
-              <a:spcAft>
-                <a:spcPts val="0"/>
-              </a:spcAft>
-            </a:pPr>
-            <a:r>
-              <a:rPr sz="1450" b="0" i="0">
-                <a:solidFill>
-                  <a:srgbClr val="0B142A"/>
-                </a:solidFill>
-                <a:latin typeface="Helvetica Neue"/>
-              </a:rPr>
-              <a:t>Ask vendors whether their SAP agent integration reads, writes, or both, and where the write path was actually tested.</a:t>
-            </a:r>
-          </a:p>
-        </p:txBody>
-      </p:sp>
-      <p:cxnSp>
-        <p:nvCxnSpPr>
-          <p:cNvPr id="12" name="Connector 11"/>
-          <p:cNvCxnSpPr/>
-          <p:nvPr/>
-        </p:nvCxnSpPr>
-        <p:spPr>
-          <a:xfrm>
-            <a:off x="640080" y="4251960"/>
-            <a:ext cx="10911535" cy="0"/>
-          </a:xfrm>
-          <a:prstGeom prst="line">
-            <a:avLst/>
-          </a:prstGeom>
-          <a:ln w="7620">
-            <a:solidFill>
-              <a:srgbClr val="DDE1E6"/>
-            </a:solidFill>
-          </a:ln>
-          <a:effectLst/>
-        </p:spPr>
-        <p:style>
-          <a:lnRef idx="2">
-            <a:schemeClr val="accent1"/>
-          </a:lnRef>
-          <a:fillRef idx="0">
-            <a:schemeClr val="accent1"/>
-          </a:fillRef>
-          <a:effectRef idx="1">
-            <a:schemeClr val="accent1"/>
-          </a:effectRef>
-          <a:fontRef idx="minor">
-            <a:schemeClr val="tx1"/>
-          </a:fontRef>
-        </p:style>
-      </p:cxnSp>
-      <p:sp>
-        <p:nvSpPr>
-          <p:cNvPr id="13" name="TextBox 12"/>
-          <p:cNvSpPr txBox="1"/>
-          <p:nvPr/>
-        </p:nvSpPr>
-        <p:spPr>
-          <a:xfrm>
-            <a:off x="640080" y="4389120"/>
-            <a:ext cx="640080" cy="548640"/>
-          </a:xfrm>
-          <a:prstGeom prst="rect">
-            <a:avLst/>
-          </a:prstGeom>
-          <a:noFill/>
-        </p:spPr>
-        <p:txBody>
-          <a:bodyPr wrap="square" anchor="t" lIns="0" rIns="0" tIns="0" bIns="0">
-            <a:spAutoFit/>
-          </a:bodyPr>
-          <a:lstStyle/>
-          <a:p>
-            <a:pPr algn="l">
-              <a:lnSpc>
-                <a:spcPct val="100000"/>
-              </a:lnSpc>
-              <a:spcAft>
-                <a:spcPts val="0"/>
-              </a:spcAft>
-            </a:pPr>
-            <a:r>
-              <a:rPr sz="2600" b="1" i="0">
-                <a:solidFill>
-                  <a:srgbClr val="0E6B6B"/>
-                </a:solidFill>
-                <a:latin typeface="Georgia"/>
-              </a:rPr>
-              <a:t>3</a:t>
-            </a:r>
-          </a:p>
-        </p:txBody>
-      </p:sp>
-      <p:sp>
-        <p:nvSpPr>
-          <p:cNvPr id="14" name="TextBox 13"/>
-          <p:cNvSpPr txBox="1"/>
-          <p:nvPr/>
-        </p:nvSpPr>
-        <p:spPr>
-          <a:xfrm>
-            <a:off x="1417320" y="4407408"/>
-            <a:ext cx="2377440" cy="822960"/>
-          </a:xfrm>
-          <a:prstGeom prst="rect">
-            <a:avLst/>
-          </a:prstGeom>
-          <a:noFill/>
-        </p:spPr>
-        <p:txBody>
-          <a:bodyPr wrap="square" anchor="t" lIns="0" rIns="0" tIns="0" bIns="0">
-            <a:spAutoFit/>
-          </a:bodyPr>
-          <a:lstStyle/>
-          <a:p>
-            <a:pPr algn="l">
-              <a:lnSpc>
-                <a:spcPct val="115000"/>
-              </a:lnSpc>
-              <a:spcAft>
-                <a:spcPts val="0"/>
-              </a:spcAft>
-            </a:pPr>
-            <a:r>
-              <a:rPr sz="1550" b="1" i="0">
-                <a:solidFill>
-                  <a:srgbClr val="0B142A"/>
-                </a:solidFill>
-                <a:latin typeface="Helvetica Neue"/>
-              </a:rPr>
-              <a:t>Platform owners</a:t>
-            </a:r>
-          </a:p>
-        </p:txBody>
-      </p:sp>
-      <p:sp>
-        <p:nvSpPr>
-          <p:cNvPr id="15" name="TextBox 14"/>
-          <p:cNvSpPr txBox="1"/>
-          <p:nvPr/>
-        </p:nvSpPr>
-        <p:spPr>
-          <a:xfrm>
-            <a:off x="3931920" y="4389120"/>
-            <a:ext cx="7680960" cy="1005840"/>
-          </a:xfrm>
-          <a:prstGeom prst="rect">
-            <a:avLst/>
-          </a:prstGeom>
-          <a:noFill/>
-        </p:spPr>
-        <p:txBody>
-          <a:bodyPr wrap="square" anchor="t" lIns="0" rIns="0" tIns="0" bIns="0">
-            <a:spAutoFit/>
-          </a:bodyPr>
-          <a:lstStyle/>
-          <a:p>
-            <a:pPr algn="l">
-              <a:lnSpc>
-                <a:spcPct val="130000"/>
-              </a:lnSpc>
-              <a:spcAft>
-                <a:spcPts val="0"/>
-              </a:spcAft>
-            </a:pPr>
-            <a:r>
-              <a:rPr sz="1450" b="0" i="0">
-                <a:solidFill>
-                  <a:srgbClr val="0B142A"/>
-                </a:solidFill>
-                <a:latin typeface="Helvetica Neue"/>
-              </a:rPr>
-              <a:t>The levers that decide agent success are unglamorous, lean responses, precise errors, and discoverable metadata.</a:t>
-            </a:r>
-          </a:p>
-        </p:txBody>
-      </p:sp>
-      <p:sp>
-        <p:nvSpPr>
-          <p:cNvPr id="16" name="Rounded Rectangle 15"/>
+              <a:t>The agent never saw SAP documentation, only error responses.</a:t>
+            </a:r>
+          </a:p>
+        </p:txBody>
+      </p:sp>
+      <p:sp>
+        <p:nvSpPr>
+          <p:cNvPr id="6" name="Rounded Rectangle 5"/>
           <p:cNvSpPr/>
           <p:nvPr/>
         </p:nvSpPr>
         <p:spPr>
           <a:xfrm>
-            <a:off x="640080" y="5623560"/>
-            <a:ext cx="10911535" cy="685800"/>
+            <a:off x="640080" y="2651760"/>
+            <a:ext cx="5120640" cy="2651760"/>
           </a:xfrm>
           <a:prstGeom prst="roundRect">
             <a:avLst>
-              <a:gd name="adj" fmla="val 12000"/>
+              <a:gd name="adj" fmla="val 5000"/>
             </a:avLst>
           </a:prstGeom>
           <a:solidFill>
@@ -3997,6 +3590,1074 @@
       </p:sp>
       <p:sp>
         <p:nvSpPr>
+          <p:cNvPr id="7" name="TextBox 6"/>
+          <p:cNvSpPr txBox="1"/>
+          <p:nvPr/>
+        </p:nvSpPr>
+        <p:spPr>
+          <a:xfrm>
+            <a:off x="960120" y="2907792"/>
+            <a:ext cx="4480560" cy="320040"/>
+          </a:xfrm>
+          <a:prstGeom prst="rect">
+            <a:avLst/>
+          </a:prstGeom>
+          <a:noFill/>
+        </p:spPr>
+        <p:txBody>
+          <a:bodyPr wrap="square" anchor="t" lIns="0" rIns="0" tIns="0" bIns="0">
+            <a:spAutoFit/>
+          </a:bodyPr>
+          <a:lstStyle/>
+          <a:p>
+            <a:pPr algn="l">
+              <a:lnSpc>
+                <a:spcPct val="100000"/>
+              </a:lnSpc>
+              <a:spcAft>
+                <a:spcPts val="0"/>
+              </a:spcAft>
+            </a:pPr>
+            <a:r>
+              <a:rPr sz="1300" b="1" i="0">
+                <a:solidFill>
+                  <a:srgbClr val="0E6B6B"/>
+                </a:solidFill>
+                <a:latin typeface="Helvetica Neue"/>
+              </a:rPr>
+              <a:t>Specific error</a:t>
+            </a:r>
+          </a:p>
+        </p:txBody>
+      </p:sp>
+      <p:sp>
+        <p:nvSpPr>
+          <p:cNvPr id="8" name="TextBox 7"/>
+          <p:cNvSpPr txBox="1"/>
+          <p:nvPr/>
+        </p:nvSpPr>
+        <p:spPr>
+          <a:xfrm>
+            <a:off x="960120" y="3273552"/>
+            <a:ext cx="4480560" cy="777240"/>
+          </a:xfrm>
+          <a:prstGeom prst="rect">
+            <a:avLst/>
+          </a:prstGeom>
+          <a:noFill/>
+        </p:spPr>
+        <p:txBody>
+          <a:bodyPr wrap="square" anchor="t" lIns="0" rIns="0" tIns="0" bIns="0">
+            <a:spAutoFit/>
+          </a:bodyPr>
+          <a:lstStyle/>
+          <a:p>
+            <a:pPr algn="l">
+              <a:lnSpc>
+                <a:spcPct val="130000"/>
+              </a:lnSpc>
+              <a:spcAft>
+                <a:spcPts val="0"/>
+              </a:spcAft>
+            </a:pPr>
+            <a:r>
+              <a:rPr sz="1350" b="0" i="1">
+                <a:solidFill>
+                  <a:srgbClr val="0B142A"/>
+                </a:solidFill>
+                <a:latin typeface="Helvetica Neue"/>
+              </a:rPr>
+              <a:t>“Property contains not found in type A_BusinessPartnerType”</a:t>
+            </a:r>
+          </a:p>
+        </p:txBody>
+      </p:sp>
+      <p:sp>
+        <p:nvSpPr>
+          <p:cNvPr id="9" name="TextBox 8"/>
+          <p:cNvSpPr txBox="1"/>
+          <p:nvPr/>
+        </p:nvSpPr>
+        <p:spPr>
+          <a:xfrm>
+            <a:off x="960120" y="4251960"/>
+            <a:ext cx="4480560" cy="822960"/>
+          </a:xfrm>
+          <a:prstGeom prst="rect">
+            <a:avLst/>
+          </a:prstGeom>
+          <a:noFill/>
+        </p:spPr>
+        <p:txBody>
+          <a:bodyPr wrap="square" anchor="t" lIns="0" rIns="0" tIns="0" bIns="0">
+            <a:spAutoFit/>
+          </a:bodyPr>
+          <a:lstStyle/>
+          <a:p>
+            <a:pPr algn="l">
+              <a:lnSpc>
+                <a:spcPct val="130000"/>
+              </a:lnSpc>
+              <a:spcAft>
+                <a:spcPts val="0"/>
+              </a:spcAft>
+            </a:pPr>
+            <a:r>
+              <a:rPr sz="1400" b="1" i="0">
+                <a:solidFill>
+                  <a:srgbClr val="0B142A"/>
+                </a:solidFill>
+                <a:latin typeface="Helvetica Neue"/>
+              </a:rPr>
+              <a:t>Result: the agent corrected course in one turn</a:t>
+            </a:r>
+          </a:p>
+        </p:txBody>
+      </p:sp>
+      <p:sp>
+        <p:nvSpPr>
+          <p:cNvPr id="10" name="Rounded Rectangle 9"/>
+          <p:cNvSpPr/>
+          <p:nvPr/>
+        </p:nvSpPr>
+        <p:spPr>
+          <a:xfrm>
+            <a:off x="6400800" y="2651760"/>
+            <a:ext cx="5120640" cy="2651760"/>
+          </a:xfrm>
+          <a:prstGeom prst="roundRect">
+            <a:avLst>
+              <a:gd name="adj" fmla="val 5000"/>
+            </a:avLst>
+          </a:prstGeom>
+          <a:solidFill>
+            <a:srgbClr val="FFFFFF"/>
+          </a:solidFill>
+          <a:ln w="12700">
+            <a:solidFill>
+              <a:srgbClr val="DDE1E6"/>
+            </a:solidFill>
+          </a:ln>
+          <a:effectLst/>
+        </p:spPr>
+        <p:style>
+          <a:lnRef idx="1">
+            <a:schemeClr val="accent1"/>
+          </a:lnRef>
+          <a:fillRef idx="3">
+            <a:schemeClr val="accent1"/>
+          </a:fillRef>
+          <a:effectRef idx="2">
+            <a:schemeClr val="accent1"/>
+          </a:effectRef>
+          <a:fontRef idx="minor">
+            <a:schemeClr val="lt1"/>
+          </a:fontRef>
+        </p:style>
+        <p:txBody>
+          <a:bodyPr rtlCol="0" anchor="ctr"/>
+          <a:lstStyle/>
+          <a:p>
+            <a:pPr algn="ctr"/>
+          </a:p>
+        </p:txBody>
+      </p:sp>
+      <p:sp>
+        <p:nvSpPr>
+          <p:cNvPr id="11" name="TextBox 10"/>
+          <p:cNvSpPr txBox="1"/>
+          <p:nvPr/>
+        </p:nvSpPr>
+        <p:spPr>
+          <a:xfrm>
+            <a:off x="6720840" y="2907792"/>
+            <a:ext cx="4480560" cy="320040"/>
+          </a:xfrm>
+          <a:prstGeom prst="rect">
+            <a:avLst/>
+          </a:prstGeom>
+          <a:noFill/>
+        </p:spPr>
+        <p:txBody>
+          <a:bodyPr wrap="square" anchor="t" lIns="0" rIns="0" tIns="0" bIns="0">
+            <a:spAutoFit/>
+          </a:bodyPr>
+          <a:lstStyle/>
+          <a:p>
+            <a:pPr algn="l">
+              <a:lnSpc>
+                <a:spcPct val="100000"/>
+              </a:lnSpc>
+              <a:spcAft>
+                <a:spcPts val="0"/>
+              </a:spcAft>
+            </a:pPr>
+            <a:r>
+              <a:rPr sz="1300" b="1" i="0">
+                <a:solidFill>
+                  <a:srgbClr val="9C3B2E"/>
+                </a:solidFill>
+                <a:latin typeface="Helvetica Neue"/>
+              </a:rPr>
+              <a:t>Vague error</a:t>
+            </a:r>
+          </a:p>
+        </p:txBody>
+      </p:sp>
+      <p:sp>
+        <p:nvSpPr>
+          <p:cNvPr id="12" name="TextBox 11"/>
+          <p:cNvSpPr txBox="1"/>
+          <p:nvPr/>
+        </p:nvSpPr>
+        <p:spPr>
+          <a:xfrm>
+            <a:off x="6720840" y="3273552"/>
+            <a:ext cx="4480560" cy="777240"/>
+          </a:xfrm>
+          <a:prstGeom prst="rect">
+            <a:avLst/>
+          </a:prstGeom>
+          <a:noFill/>
+        </p:spPr>
+        <p:txBody>
+          <a:bodyPr wrap="square" anchor="t" lIns="0" rIns="0" tIns="0" bIns="0">
+            <a:spAutoFit/>
+          </a:bodyPr>
+          <a:lstStyle/>
+          <a:p>
+            <a:pPr algn="l">
+              <a:lnSpc>
+                <a:spcPct val="130000"/>
+              </a:lnSpc>
+              <a:spcAft>
+                <a:spcPts val="0"/>
+              </a:spcAft>
+            </a:pPr>
+            <a:r>
+              <a:rPr sz="1350" b="0" i="1">
+                <a:solidFill>
+                  <a:srgbClr val="0B142A"/>
+                </a:solidFill>
+                <a:latin typeface="Helvetica Neue"/>
+              </a:rPr>
+              <a:t>Generic not found or rejected responses with no field level detail</a:t>
+            </a:r>
+          </a:p>
+        </p:txBody>
+      </p:sp>
+      <p:sp>
+        <p:nvSpPr>
+          <p:cNvPr id="13" name="TextBox 12"/>
+          <p:cNvSpPr txBox="1"/>
+          <p:nvPr/>
+        </p:nvSpPr>
+        <p:spPr>
+          <a:xfrm>
+            <a:off x="6720840" y="4251960"/>
+            <a:ext cx="4480560" cy="822960"/>
+          </a:xfrm>
+          <a:prstGeom prst="rect">
+            <a:avLst/>
+          </a:prstGeom>
+          <a:noFill/>
+        </p:spPr>
+        <p:txBody>
+          <a:bodyPr wrap="square" anchor="t" lIns="0" rIns="0" tIns="0" bIns="0">
+            <a:spAutoFit/>
+          </a:bodyPr>
+          <a:lstStyle/>
+          <a:p>
+            <a:pPr algn="l">
+              <a:lnSpc>
+                <a:spcPct val="130000"/>
+              </a:lnSpc>
+              <a:spcAft>
+                <a:spcPts val="0"/>
+              </a:spcAft>
+            </a:pPr>
+            <a:r>
+              <a:rPr sz="1400" b="1" i="0">
+                <a:solidFill>
+                  <a:srgbClr val="0B142A"/>
+                </a:solidFill>
+                <a:latin typeface="Helvetica Neue"/>
+              </a:rPr>
+              <a:t>Result: repeated failing guesses</a:t>
+            </a:r>
+          </a:p>
+        </p:txBody>
+      </p:sp>
+      <p:sp>
+        <p:nvSpPr>
+          <p:cNvPr id="14" name="TextBox 13"/>
+          <p:cNvSpPr txBox="1"/>
+          <p:nvPr/>
+        </p:nvSpPr>
+        <p:spPr>
+          <a:xfrm>
+            <a:off x="640080" y="5623560"/>
+            <a:ext cx="10881360" cy="640080"/>
+          </a:xfrm>
+          <a:prstGeom prst="rect">
+            <a:avLst/>
+          </a:prstGeom>
+          <a:noFill/>
+        </p:spPr>
+        <p:txBody>
+          <a:bodyPr wrap="square" anchor="t" lIns="0" rIns="0" tIns="0" bIns="0">
+            <a:spAutoFit/>
+          </a:bodyPr>
+          <a:lstStyle/>
+          <a:p>
+            <a:pPr algn="l">
+              <a:lnSpc>
+                <a:spcPct val="130000"/>
+              </a:lnSpc>
+              <a:spcAft>
+                <a:spcPts val="0"/>
+              </a:spcAft>
+            </a:pPr>
+            <a:r>
+              <a:rPr sz="1400" b="0" i="1">
+                <a:solidFill>
+                  <a:srgbClr val="6B7280"/>
+                </a:solidFill>
+                <a:latin typeface="Helvetica Neue"/>
+              </a:rPr>
+              <a:t>For API owners preparing for agent traffic, error message quality is no longer a developer nicety, it is the interface.</a:t>
+            </a:r>
+          </a:p>
+        </p:txBody>
+      </p:sp>
+      <p:sp>
+        <p:nvSpPr>
+          <p:cNvPr id="15" name="TextBox 14"/>
+          <p:cNvSpPr txBox="1"/>
+          <p:nvPr/>
+        </p:nvSpPr>
+        <p:spPr>
+          <a:xfrm>
+            <a:off x="640080" y="6492240"/>
+            <a:ext cx="5486400" cy="274320"/>
+          </a:xfrm>
+          <a:prstGeom prst="rect">
+            <a:avLst/>
+          </a:prstGeom>
+          <a:noFill/>
+        </p:spPr>
+        <p:txBody>
+          <a:bodyPr wrap="square" anchor="t" lIns="0" rIns="0" tIns="0" bIns="0">
+            <a:spAutoFit/>
+          </a:bodyPr>
+          <a:lstStyle/>
+          <a:p>
+            <a:pPr algn="l">
+              <a:lnSpc>
+                <a:spcPct val="100000"/>
+              </a:lnSpc>
+              <a:spcAft>
+                <a:spcPts val="0"/>
+              </a:spcAft>
+            </a:pPr>
+            <a:r>
+              <a:rPr sz="950" b="0" i="0">
+                <a:solidFill>
+                  <a:srgbClr val="6B7280"/>
+                </a:solidFill>
+                <a:latin typeface="Helvetica Neue"/>
+              </a:rPr>
+              <a:t>Can an AI agent operate an ERP? — July 2026 study</a:t>
+            </a:r>
+          </a:p>
+        </p:txBody>
+      </p:sp>
+      <p:sp>
+        <p:nvSpPr>
+          <p:cNvPr id="16" name="TextBox 15"/>
+          <p:cNvSpPr txBox="1"/>
+          <p:nvPr/>
+        </p:nvSpPr>
+        <p:spPr>
+          <a:xfrm>
+            <a:off x="10180015" y="6492240"/>
+            <a:ext cx="1371600" cy="274320"/>
+          </a:xfrm>
+          <a:prstGeom prst="rect">
+            <a:avLst/>
+          </a:prstGeom>
+          <a:noFill/>
+        </p:spPr>
+        <p:txBody>
+          <a:bodyPr wrap="square" anchor="t" lIns="0" rIns="0" tIns="0" bIns="0">
+            <a:spAutoFit/>
+          </a:bodyPr>
+          <a:lstStyle/>
+          <a:p>
+            <a:pPr algn="r">
+              <a:lnSpc>
+                <a:spcPct val="100000"/>
+              </a:lnSpc>
+              <a:spcAft>
+                <a:spcPts val="0"/>
+              </a:spcAft>
+            </a:pPr>
+            <a:r>
+              <a:rPr sz="950" b="0" i="0">
+                <a:solidFill>
+                  <a:srgbClr val="6B7280"/>
+                </a:solidFill>
+                <a:latin typeface="Helvetica Neue"/>
+              </a:rPr>
+              <a:t>10 / 11</a:t>
+            </a:r>
+          </a:p>
+        </p:txBody>
+      </p:sp>
+    </p:spTree>
+  </p:cSld>
+  <p:clrMapOvr>
+    <a:masterClrMapping/>
+  </p:clrMapOvr>
+</p:sld>
+</file>
+
+<file path=ppt/slides/slide11.xml><?xml version="1.0" encoding="utf-8"?>
+<p:sld xmlns:a="http://schemas.openxmlformats.org/drawingml/2006/main" xmlns:p="http://schemas.openxmlformats.org/presentationml/2006/main" xmlns:r="http://schemas.openxmlformats.org/officeDocument/2006/relationships">
+  <p:cSld>
+    <p:bg>
+      <p:bgPr>
+        <a:solidFill>
+          <a:srgbClr val="FFFFFF"/>
+        </a:solidFill>
+        <a:effectLst/>
+      </p:bgPr>
+    </p:bg>
+    <p:spTree>
+      <p:nvGrpSpPr>
+        <p:cNvPr id="1" name=""/>
+        <p:cNvGrpSpPr/>
+        <p:nvPr/>
+      </p:nvGrpSpPr>
+      <p:grpSpPr/>
+      <p:sp>
+        <p:nvSpPr>
+          <p:cNvPr id="2" name="TextBox 1"/>
+          <p:cNvSpPr txBox="1"/>
+          <p:nvPr/>
+        </p:nvSpPr>
+        <p:spPr>
+          <a:xfrm>
+            <a:off x="640080" y="457200"/>
+            <a:ext cx="7315200" cy="320040"/>
+          </a:xfrm>
+          <a:prstGeom prst="rect">
+            <a:avLst/>
+          </a:prstGeom>
+          <a:noFill/>
+        </p:spPr>
+        <p:txBody>
+          <a:bodyPr wrap="square" anchor="t" lIns="0" rIns="0" tIns="0" bIns="0">
+            <a:spAutoFit/>
+          </a:bodyPr>
+          <a:lstStyle/>
+          <a:p>
+            <a:pPr algn="l">
+              <a:lnSpc>
+                <a:spcPct val="100000"/>
+              </a:lnSpc>
+              <a:spcAft>
+                <a:spcPts val="0"/>
+              </a:spcAft>
+            </a:pPr>
+            <a:r>
+              <a:rPr sz="1250" b="1" i="0">
+                <a:solidFill>
+                  <a:srgbClr val="0E6B6B"/>
+                </a:solidFill>
+                <a:latin typeface="Helvetica Neue"/>
+              </a:rPr>
+              <a:t>WHAT THIS MEANS</a:t>
+            </a:r>
+          </a:p>
+        </p:txBody>
+      </p:sp>
+      <p:sp>
+        <p:nvSpPr>
+          <p:cNvPr id="3" name="TextBox 2"/>
+          <p:cNvSpPr txBox="1"/>
+          <p:nvPr/>
+        </p:nvSpPr>
+        <p:spPr>
+          <a:xfrm>
+            <a:off x="640080" y="749808"/>
+            <a:ext cx="10881360" cy="822960"/>
+          </a:xfrm>
+          <a:prstGeom prst="rect">
+            <a:avLst/>
+          </a:prstGeom>
+          <a:noFill/>
+        </p:spPr>
+        <p:txBody>
+          <a:bodyPr wrap="square" anchor="t" lIns="0" rIns="0" tIns="0" bIns="0">
+            <a:spAutoFit/>
+          </a:bodyPr>
+          <a:lstStyle/>
+          <a:p>
+            <a:pPr algn="l">
+              <a:lnSpc>
+                <a:spcPct val="100000"/>
+              </a:lnSpc>
+              <a:spcAft>
+                <a:spcPts val="0"/>
+              </a:spcAft>
+            </a:pPr>
+            <a:r>
+              <a:rPr sz="3000" b="1" i="0">
+                <a:solidFill>
+                  <a:srgbClr val="0B142A"/>
+                </a:solidFill>
+                <a:latin typeface="Georgia"/>
+              </a:rPr>
+              <a:t>Three implications, for three audiences</a:t>
+            </a:r>
+          </a:p>
+        </p:txBody>
+      </p:sp>
+      <p:cxnSp>
+        <p:nvCxnSpPr>
+          <p:cNvPr id="4" name="Connector 3"/>
+          <p:cNvCxnSpPr/>
+          <p:nvPr/>
+        </p:nvCxnSpPr>
+        <p:spPr>
+          <a:xfrm>
+            <a:off x="640080" y="1481328"/>
+            <a:ext cx="10911535" cy="0"/>
+          </a:xfrm>
+          <a:prstGeom prst="line">
+            <a:avLst/>
+          </a:prstGeom>
+          <a:ln w="12700">
+            <a:solidFill>
+              <a:srgbClr val="DDE1E6"/>
+            </a:solidFill>
+          </a:ln>
+          <a:effectLst/>
+        </p:spPr>
+        <p:style>
+          <a:lnRef idx="2">
+            <a:schemeClr val="accent1"/>
+          </a:lnRef>
+          <a:fillRef idx="0">
+            <a:schemeClr val="accent1"/>
+          </a:fillRef>
+          <a:effectRef idx="1">
+            <a:schemeClr val="accent1"/>
+          </a:effectRef>
+          <a:fontRef idx="minor">
+            <a:schemeClr val="tx1"/>
+          </a:fontRef>
+        </p:style>
+      </p:cxnSp>
+      <p:sp>
+        <p:nvSpPr>
+          <p:cNvPr id="5" name="TextBox 4"/>
+          <p:cNvSpPr txBox="1"/>
+          <p:nvPr/>
+        </p:nvSpPr>
+        <p:spPr>
+          <a:xfrm>
+            <a:off x="640080" y="1920240"/>
+            <a:ext cx="640080" cy="548640"/>
+          </a:xfrm>
+          <a:prstGeom prst="rect">
+            <a:avLst/>
+          </a:prstGeom>
+          <a:noFill/>
+        </p:spPr>
+        <p:txBody>
+          <a:bodyPr wrap="square" anchor="t" lIns="0" rIns="0" tIns="0" bIns="0">
+            <a:spAutoFit/>
+          </a:bodyPr>
+          <a:lstStyle/>
+          <a:p>
+            <a:pPr algn="l">
+              <a:lnSpc>
+                <a:spcPct val="100000"/>
+              </a:lnSpc>
+              <a:spcAft>
+                <a:spcPts val="0"/>
+              </a:spcAft>
+            </a:pPr>
+            <a:r>
+              <a:rPr sz="2600" b="1" i="0">
+                <a:solidFill>
+                  <a:srgbClr val="0E6B6B"/>
+                </a:solidFill>
+                <a:latin typeface="Georgia"/>
+              </a:rPr>
+              <a:t>1</a:t>
+            </a:r>
+          </a:p>
+        </p:txBody>
+      </p:sp>
+      <p:sp>
+        <p:nvSpPr>
+          <p:cNvPr id="6" name="TextBox 5"/>
+          <p:cNvSpPr txBox="1"/>
+          <p:nvPr/>
+        </p:nvSpPr>
+        <p:spPr>
+          <a:xfrm>
+            <a:off x="1417320" y="1938528"/>
+            <a:ext cx="2377440" cy="822960"/>
+          </a:xfrm>
+          <a:prstGeom prst="rect">
+            <a:avLst/>
+          </a:prstGeom>
+          <a:noFill/>
+        </p:spPr>
+        <p:txBody>
+          <a:bodyPr wrap="square" anchor="t" lIns="0" rIns="0" tIns="0" bIns="0">
+            <a:spAutoFit/>
+          </a:bodyPr>
+          <a:lstStyle/>
+          <a:p>
+            <a:pPr algn="l">
+              <a:lnSpc>
+                <a:spcPct val="115000"/>
+              </a:lnSpc>
+              <a:spcAft>
+                <a:spcPts val="0"/>
+              </a:spcAft>
+            </a:pPr>
+            <a:r>
+              <a:rPr sz="1550" b="1" i="0">
+                <a:solidFill>
+                  <a:srgbClr val="0B142A"/>
+                </a:solidFill>
+                <a:latin typeface="Helvetica Neue"/>
+              </a:rPr>
+              <a:t>Agent builders</a:t>
+            </a:r>
+          </a:p>
+        </p:txBody>
+      </p:sp>
+      <p:sp>
+        <p:nvSpPr>
+          <p:cNvPr id="7" name="TextBox 6"/>
+          <p:cNvSpPr txBox="1"/>
+          <p:nvPr/>
+        </p:nvSpPr>
+        <p:spPr>
+          <a:xfrm>
+            <a:off x="3931920" y="1920240"/>
+            <a:ext cx="7680960" cy="1005840"/>
+          </a:xfrm>
+          <a:prstGeom prst="rect">
+            <a:avLst/>
+          </a:prstGeom>
+          <a:noFill/>
+        </p:spPr>
+        <p:txBody>
+          <a:bodyPr wrap="square" anchor="t" lIns="0" rIns="0" tIns="0" bIns="0">
+            <a:spAutoFit/>
+          </a:bodyPr>
+          <a:lstStyle/>
+          <a:p>
+            <a:pPr algn="l">
+              <a:lnSpc>
+                <a:spcPct val="130000"/>
+              </a:lnSpc>
+              <a:spcAft>
+                <a:spcPts val="0"/>
+              </a:spcAft>
+            </a:pPr>
+            <a:r>
+              <a:rPr sz="1450" b="0" i="0">
+                <a:solidFill>
+                  <a:srgbClr val="0B142A"/>
+                </a:solidFill>
+                <a:latin typeface="Helvetica Neue"/>
+              </a:rPr>
+              <a:t>Budget for the discovery problem. Agents will need curated tool definitions or metadata access, not raw OData endpoints and optimism.</a:t>
+            </a:r>
+          </a:p>
+        </p:txBody>
+      </p:sp>
+      <p:cxnSp>
+        <p:nvCxnSpPr>
+          <p:cNvPr id="8" name="Connector 7"/>
+          <p:cNvCxnSpPr/>
+          <p:nvPr/>
+        </p:nvCxnSpPr>
+        <p:spPr>
+          <a:xfrm>
+            <a:off x="640080" y="3017520"/>
+            <a:ext cx="10911535" cy="0"/>
+          </a:xfrm>
+          <a:prstGeom prst="line">
+            <a:avLst/>
+          </a:prstGeom>
+          <a:ln w="7620">
+            <a:solidFill>
+              <a:srgbClr val="DDE1E6"/>
+            </a:solidFill>
+          </a:ln>
+          <a:effectLst/>
+        </p:spPr>
+        <p:style>
+          <a:lnRef idx="2">
+            <a:schemeClr val="accent1"/>
+          </a:lnRef>
+          <a:fillRef idx="0">
+            <a:schemeClr val="accent1"/>
+          </a:fillRef>
+          <a:effectRef idx="1">
+            <a:schemeClr val="accent1"/>
+          </a:effectRef>
+          <a:fontRef idx="minor">
+            <a:schemeClr val="tx1"/>
+          </a:fontRef>
+        </p:style>
+      </p:cxnSp>
+      <p:sp>
+        <p:nvSpPr>
+          <p:cNvPr id="9" name="TextBox 8"/>
+          <p:cNvSpPr txBox="1"/>
+          <p:nvPr/>
+        </p:nvSpPr>
+        <p:spPr>
+          <a:xfrm>
+            <a:off x="640080" y="3154680"/>
+            <a:ext cx="640080" cy="548640"/>
+          </a:xfrm>
+          <a:prstGeom prst="rect">
+            <a:avLst/>
+          </a:prstGeom>
+          <a:noFill/>
+        </p:spPr>
+        <p:txBody>
+          <a:bodyPr wrap="square" anchor="t" lIns="0" rIns="0" tIns="0" bIns="0">
+            <a:spAutoFit/>
+          </a:bodyPr>
+          <a:lstStyle/>
+          <a:p>
+            <a:pPr algn="l">
+              <a:lnSpc>
+                <a:spcPct val="100000"/>
+              </a:lnSpc>
+              <a:spcAft>
+                <a:spcPts val="0"/>
+              </a:spcAft>
+            </a:pPr>
+            <a:r>
+              <a:rPr sz="2600" b="1" i="0">
+                <a:solidFill>
+                  <a:srgbClr val="0E6B6B"/>
+                </a:solidFill>
+                <a:latin typeface="Georgia"/>
+              </a:rPr>
+              <a:t>2</a:t>
+            </a:r>
+          </a:p>
+        </p:txBody>
+      </p:sp>
+      <p:sp>
+        <p:nvSpPr>
+          <p:cNvPr id="10" name="TextBox 9"/>
+          <p:cNvSpPr txBox="1"/>
+          <p:nvPr/>
+        </p:nvSpPr>
+        <p:spPr>
+          <a:xfrm>
+            <a:off x="1417320" y="3172968"/>
+            <a:ext cx="2377440" cy="822960"/>
+          </a:xfrm>
+          <a:prstGeom prst="rect">
+            <a:avLst/>
+          </a:prstGeom>
+          <a:noFill/>
+        </p:spPr>
+        <p:txBody>
+          <a:bodyPr wrap="square" anchor="t" lIns="0" rIns="0" tIns="0" bIns="0">
+            <a:spAutoFit/>
+          </a:bodyPr>
+          <a:lstStyle/>
+          <a:p>
+            <a:pPr algn="l">
+              <a:lnSpc>
+                <a:spcPct val="115000"/>
+              </a:lnSpc>
+              <a:spcAft>
+                <a:spcPts val="0"/>
+              </a:spcAft>
+            </a:pPr>
+            <a:r>
+              <a:rPr sz="1550" b="1" i="0">
+                <a:solidFill>
+                  <a:srgbClr val="0B142A"/>
+                </a:solidFill>
+                <a:latin typeface="Helvetica Neue"/>
+              </a:rPr>
+              <a:t>Buyers</a:t>
+            </a:r>
+          </a:p>
+        </p:txBody>
+      </p:sp>
+      <p:sp>
+        <p:nvSpPr>
+          <p:cNvPr id="11" name="TextBox 10"/>
+          <p:cNvSpPr txBox="1"/>
+          <p:nvPr/>
+        </p:nvSpPr>
+        <p:spPr>
+          <a:xfrm>
+            <a:off x="3931920" y="3154680"/>
+            <a:ext cx="7680960" cy="1005840"/>
+          </a:xfrm>
+          <a:prstGeom prst="rect">
+            <a:avLst/>
+          </a:prstGeom>
+          <a:noFill/>
+        </p:spPr>
+        <p:txBody>
+          <a:bodyPr wrap="square" anchor="t" lIns="0" rIns="0" tIns="0" bIns="0">
+            <a:spAutoFit/>
+          </a:bodyPr>
+          <a:lstStyle/>
+          <a:p>
+            <a:pPr algn="l">
+              <a:lnSpc>
+                <a:spcPct val="130000"/>
+              </a:lnSpc>
+              <a:spcAft>
+                <a:spcPts val="0"/>
+              </a:spcAft>
+            </a:pPr>
+            <a:r>
+              <a:rPr sz="1450" b="0" i="0">
+                <a:solidFill>
+                  <a:srgbClr val="0B142A"/>
+                </a:solidFill>
+                <a:latin typeface="Helvetica Neue"/>
+              </a:rPr>
+              <a:t>Ask vendors whether their SAP agent integration reads, writes, or both, and where the write path was actually tested.</a:t>
+            </a:r>
+          </a:p>
+        </p:txBody>
+      </p:sp>
+      <p:cxnSp>
+        <p:nvCxnSpPr>
+          <p:cNvPr id="12" name="Connector 11"/>
+          <p:cNvCxnSpPr/>
+          <p:nvPr/>
+        </p:nvCxnSpPr>
+        <p:spPr>
+          <a:xfrm>
+            <a:off x="640080" y="4251960"/>
+            <a:ext cx="10911535" cy="0"/>
+          </a:xfrm>
+          <a:prstGeom prst="line">
+            <a:avLst/>
+          </a:prstGeom>
+          <a:ln w="7620">
+            <a:solidFill>
+              <a:srgbClr val="DDE1E6"/>
+            </a:solidFill>
+          </a:ln>
+          <a:effectLst/>
+        </p:spPr>
+        <p:style>
+          <a:lnRef idx="2">
+            <a:schemeClr val="accent1"/>
+          </a:lnRef>
+          <a:fillRef idx="0">
+            <a:schemeClr val="accent1"/>
+          </a:fillRef>
+          <a:effectRef idx="1">
+            <a:schemeClr val="accent1"/>
+          </a:effectRef>
+          <a:fontRef idx="minor">
+            <a:schemeClr val="tx1"/>
+          </a:fontRef>
+        </p:style>
+      </p:cxnSp>
+      <p:sp>
+        <p:nvSpPr>
+          <p:cNvPr id="13" name="TextBox 12"/>
+          <p:cNvSpPr txBox="1"/>
+          <p:nvPr/>
+        </p:nvSpPr>
+        <p:spPr>
+          <a:xfrm>
+            <a:off x="640080" y="4389120"/>
+            <a:ext cx="640080" cy="548640"/>
+          </a:xfrm>
+          <a:prstGeom prst="rect">
+            <a:avLst/>
+          </a:prstGeom>
+          <a:noFill/>
+        </p:spPr>
+        <p:txBody>
+          <a:bodyPr wrap="square" anchor="t" lIns="0" rIns="0" tIns="0" bIns="0">
+            <a:spAutoFit/>
+          </a:bodyPr>
+          <a:lstStyle/>
+          <a:p>
+            <a:pPr algn="l">
+              <a:lnSpc>
+                <a:spcPct val="100000"/>
+              </a:lnSpc>
+              <a:spcAft>
+                <a:spcPts val="0"/>
+              </a:spcAft>
+            </a:pPr>
+            <a:r>
+              <a:rPr sz="2600" b="1" i="0">
+                <a:solidFill>
+                  <a:srgbClr val="0E6B6B"/>
+                </a:solidFill>
+                <a:latin typeface="Georgia"/>
+              </a:rPr>
+              <a:t>3</a:t>
+            </a:r>
+          </a:p>
+        </p:txBody>
+      </p:sp>
+      <p:sp>
+        <p:nvSpPr>
+          <p:cNvPr id="14" name="TextBox 13"/>
+          <p:cNvSpPr txBox="1"/>
+          <p:nvPr/>
+        </p:nvSpPr>
+        <p:spPr>
+          <a:xfrm>
+            <a:off x="1417320" y="4407408"/>
+            <a:ext cx="2377440" cy="822960"/>
+          </a:xfrm>
+          <a:prstGeom prst="rect">
+            <a:avLst/>
+          </a:prstGeom>
+          <a:noFill/>
+        </p:spPr>
+        <p:txBody>
+          <a:bodyPr wrap="square" anchor="t" lIns="0" rIns="0" tIns="0" bIns="0">
+            <a:spAutoFit/>
+          </a:bodyPr>
+          <a:lstStyle/>
+          <a:p>
+            <a:pPr algn="l">
+              <a:lnSpc>
+                <a:spcPct val="115000"/>
+              </a:lnSpc>
+              <a:spcAft>
+                <a:spcPts val="0"/>
+              </a:spcAft>
+            </a:pPr>
+            <a:r>
+              <a:rPr sz="1550" b="1" i="0">
+                <a:solidFill>
+                  <a:srgbClr val="0B142A"/>
+                </a:solidFill>
+                <a:latin typeface="Helvetica Neue"/>
+              </a:rPr>
+              <a:t>Platform owners</a:t>
+            </a:r>
+          </a:p>
+        </p:txBody>
+      </p:sp>
+      <p:sp>
+        <p:nvSpPr>
+          <p:cNvPr id="15" name="TextBox 14"/>
+          <p:cNvSpPr txBox="1"/>
+          <p:nvPr/>
+        </p:nvSpPr>
+        <p:spPr>
+          <a:xfrm>
+            <a:off x="3931920" y="4389120"/>
+            <a:ext cx="7680960" cy="1005840"/>
+          </a:xfrm>
+          <a:prstGeom prst="rect">
+            <a:avLst/>
+          </a:prstGeom>
+          <a:noFill/>
+        </p:spPr>
+        <p:txBody>
+          <a:bodyPr wrap="square" anchor="t" lIns="0" rIns="0" tIns="0" bIns="0">
+            <a:spAutoFit/>
+          </a:bodyPr>
+          <a:lstStyle/>
+          <a:p>
+            <a:pPr algn="l">
+              <a:lnSpc>
+                <a:spcPct val="130000"/>
+              </a:lnSpc>
+              <a:spcAft>
+                <a:spcPts val="0"/>
+              </a:spcAft>
+            </a:pPr>
+            <a:r>
+              <a:rPr sz="1450" b="0" i="0">
+                <a:solidFill>
+                  <a:srgbClr val="0B142A"/>
+                </a:solidFill>
+                <a:latin typeface="Helvetica Neue"/>
+              </a:rPr>
+              <a:t>The levers that decide agent success are unglamorous, lean responses, precise errors, and discoverable metadata.</a:t>
+            </a:r>
+          </a:p>
+        </p:txBody>
+      </p:sp>
+      <p:sp>
+        <p:nvSpPr>
+          <p:cNvPr id="16" name="Rounded Rectangle 15"/>
+          <p:cNvSpPr/>
+          <p:nvPr/>
+        </p:nvSpPr>
+        <p:spPr>
+          <a:xfrm>
+            <a:off x="640080" y="5623560"/>
+            <a:ext cx="10911535" cy="685800"/>
+          </a:xfrm>
+          <a:prstGeom prst="roundRect">
+            <a:avLst>
+              <a:gd name="adj" fmla="val 12000"/>
+            </a:avLst>
+          </a:prstGeom>
+          <a:solidFill>
+            <a:srgbClr val="E4F0EF"/>
+          </a:solidFill>
+          <a:ln>
+            <a:noFill/>
+          </a:ln>
+          <a:effectLst/>
+        </p:spPr>
+        <p:style>
+          <a:lnRef idx="1">
+            <a:schemeClr val="accent1"/>
+          </a:lnRef>
+          <a:fillRef idx="3">
+            <a:schemeClr val="accent1"/>
+          </a:fillRef>
+          <a:effectRef idx="2">
+            <a:schemeClr val="accent1"/>
+          </a:effectRef>
+          <a:fontRef idx="minor">
+            <a:schemeClr val="lt1"/>
+          </a:fontRef>
+        </p:style>
+        <p:txBody>
+          <a:bodyPr rtlCol="0" anchor="ctr"/>
+          <a:lstStyle/>
+          <a:p>
+            <a:pPr algn="ctr"/>
+          </a:p>
+        </p:txBody>
+      </p:sp>
+      <p:sp>
+        <p:nvSpPr>
           <p:cNvPr id="17" name="TextBox 16"/>
           <p:cNvSpPr txBox="1"/>
           <p:nvPr/>
@@ -4116,7 +4777,7 @@
                 </a:solidFill>
                 <a:latin typeface="Helvetica Neue"/>
               </a:rPr>
-              <a:t>10 / 10</a:t>
+              <a:t>11 / 11</a:t>
             </a:r>
           </a:p>
         </p:txBody>
@@ -4695,7 +5356,7 @@
                 </a:solidFill>
                 <a:latin typeface="Helvetica Neue"/>
               </a:rPr>
-              <a:t>02 / 10</a:t>
+              <a:t>02 / 11</a:t>
             </a:r>
           </a:p>
         </p:txBody>
@@ -5700,7 +6361,7 @@
                 </a:solidFill>
                 <a:latin typeface="Helvetica Neue"/>
               </a:rPr>
-              <a:t>03 / 10</a:t>
+              <a:t>03 / 11</a:t>
             </a:r>
           </a:p>
         </p:txBody>
@@ -6704,7 +7365,7 @@
                 </a:solidFill>
                 <a:latin typeface="Helvetica Neue"/>
               </a:rPr>
-              <a:t>04 / 10</a:t>
+              <a:t>04 / 11</a:t>
             </a:r>
           </a:p>
         </p:txBody>
@@ -8339,7 +9000,7 @@
                 </a:solidFill>
                 <a:latin typeface="Helvetica Neue"/>
               </a:rPr>
-              <a:t>05 / 10</a:t>
+              <a:t>05 / 11</a:t>
             </a:r>
           </a:p>
         </p:txBody>
@@ -8407,7 +9068,7 @@
                 </a:solidFill>
                 <a:latin typeface="Helvetica Neue"/>
               </a:rPr>
-              <a:t>FINDING 1</a:t>
+              <a:t>MODEL COMPARISON</a:t>
             </a:r>
           </a:p>
         </p:txBody>
@@ -8449,7 +9110,7 @@
                 </a:solidFill>
                 <a:latin typeface="Georgia"/>
               </a:rPr>
-              <a:t>Reading works, but discovery is expensive</a:t>
+              <a:t>Does a smarter brain fix it?</a:t>
             </a:r>
           </a:p>
         </p:txBody>
@@ -8498,8 +9159,8 @@
         </p:nvSpPr>
         <p:spPr>
           <a:xfrm>
-            <a:off x="640080" y="1828800"/>
-            <a:ext cx="3383280" cy="685800"/>
+            <a:off x="640080" y="1691640"/>
+            <a:ext cx="10881360" cy="548640"/>
           </a:xfrm>
           <a:prstGeom prst="rect">
             <a:avLst/>
@@ -8514,293 +9175,41 @@
           <a:p>
             <a:pPr algn="l">
               <a:lnSpc>
-                <a:spcPct val="100000"/>
-              </a:lnSpc>
-              <a:spcAft>
-                <a:spcPts val="0"/>
-              </a:spcAft>
-            </a:pPr>
-            <a:r>
-              <a:rPr sz="5200" b="1" i="0">
-                <a:solidFill>
-                  <a:srgbClr val="0E6B6B"/>
-                </a:solidFill>
-                <a:latin typeface="Georgia"/>
-              </a:rPr>
-              <a:t>11</a:t>
-            </a:r>
-          </a:p>
-        </p:txBody>
-      </p:sp>
-      <p:sp>
-        <p:nvSpPr>
-          <p:cNvPr id="6" name="TextBox 5"/>
-          <p:cNvSpPr txBox="1"/>
-          <p:nvPr/>
-        </p:nvSpPr>
-        <p:spPr>
-          <a:xfrm>
-            <a:off x="640080" y="2606871"/>
-            <a:ext cx="3383280" cy="548640"/>
-          </a:xfrm>
-          <a:prstGeom prst="rect">
-            <a:avLst/>
-          </a:prstGeom>
-          <a:noFill/>
-        </p:spPr>
-        <p:txBody>
-          <a:bodyPr wrap="square" anchor="t" lIns="0" rIns="0" tIns="0" bIns="0">
-            <a:spAutoFit/>
-          </a:bodyPr>
-          <a:lstStyle/>
-          <a:p>
-            <a:pPr algn="l">
-              <a:lnSpc>
-                <a:spcPct val="115000"/>
-              </a:lnSpc>
-              <a:spcAft>
-                <a:spcPts val="0"/>
-              </a:spcAft>
-            </a:pPr>
-            <a:r>
-              <a:rPr sz="1250" b="0" i="0">
-                <a:solidFill>
-                  <a:srgbClr val="6B7280"/>
-                </a:solidFill>
-                <a:latin typeface="Helvetica Neue"/>
-              </a:rPr>
-              <a:t>API calls to find</a:t>
-            </a:r>
-          </a:p>
-          <a:p>
-            <a:pPr algn="l">
-              <a:lnSpc>
-                <a:spcPct val="115000"/>
-              </a:lnSpc>
-              <a:spcAft>
-                <a:spcPts val="0"/>
-              </a:spcAft>
-            </a:pPr>
-            <a:r>
-              <a:rPr sz="1250" b="0" i="0">
-                <a:solidFill>
-                  <a:srgbClr val="6B7280"/>
-                </a:solidFill>
-                <a:latin typeface="Helvetica Neue"/>
-              </a:rPr>
-              <a:t>one supplier by name</a:t>
-            </a:r>
-          </a:p>
-        </p:txBody>
-      </p:sp>
-      <p:sp>
-        <p:nvSpPr>
-          <p:cNvPr id="7" name="TextBox 6"/>
-          <p:cNvSpPr txBox="1"/>
-          <p:nvPr/>
-        </p:nvSpPr>
-        <p:spPr>
-          <a:xfrm>
-            <a:off x="640080" y="3657600"/>
-            <a:ext cx="3383280" cy="2377440"/>
-          </a:xfrm>
-          <a:prstGeom prst="rect">
-            <a:avLst/>
-          </a:prstGeom>
-          <a:noFill/>
-        </p:spPr>
-        <p:txBody>
-          <a:bodyPr wrap="square" anchor="t" lIns="0" rIns="0" tIns="0" bIns="0">
-            <a:spAutoFit/>
-          </a:bodyPr>
-          <a:lstStyle/>
-          <a:p>
-            <a:pPr algn="l">
-              <a:lnSpc>
-                <a:spcPct val="130000"/>
-              </a:lnSpc>
-              <a:spcAft>
-                <a:spcPts val="0"/>
-              </a:spcAft>
-            </a:pPr>
-            <a:r>
-              <a:rPr sz="1450" b="0" i="0">
+                <a:spcPct val="125000"/>
+              </a:lnSpc>
+              <a:spcAft>
+                <a:spcPts val="0"/>
+              </a:spcAft>
+            </a:pPr>
+            <a:r>
+              <a:rPr sz="1500" b="0" i="0">
                 <a:solidFill>
                   <a:srgbClr val="0B142A"/>
                 </a:solidFill>
                 <a:latin typeface="Helvetica Neue"/>
               </a:rPr>
-              <a:t>The agent completed every read task. But the simplest sounding one, find one supplier by name, took 11 calls because the agent had to discover SAP's data model by trial and error.</a:t>
-            </a:r>
-          </a:p>
-        </p:txBody>
-      </p:sp>
-      <p:sp>
-        <p:nvSpPr>
-          <p:cNvPr id="8" name="Rounded Rectangle 7"/>
-          <p:cNvSpPr/>
-          <p:nvPr/>
-        </p:nvSpPr>
-        <p:spPr>
-          <a:xfrm>
-            <a:off x="4937760" y="1828800"/>
-            <a:ext cx="6613855" cy="3566160"/>
-          </a:xfrm>
-          <a:prstGeom prst="roundRect">
-            <a:avLst>
-              <a:gd name="adj" fmla="val 5000"/>
-            </a:avLst>
-          </a:prstGeom>
-          <a:solidFill>
-            <a:srgbClr val="E4F0EF"/>
-          </a:solidFill>
-          <a:ln>
-            <a:noFill/>
-          </a:ln>
-          <a:effectLst/>
-        </p:spPr>
-        <p:style>
-          <a:lnRef idx="1">
-            <a:schemeClr val="accent1"/>
-          </a:lnRef>
-          <a:fillRef idx="3">
-            <a:schemeClr val="accent1"/>
-          </a:fillRef>
-          <a:effectRef idx="2">
-            <a:schemeClr val="accent1"/>
-          </a:effectRef>
-          <a:fontRef idx="minor">
-            <a:schemeClr val="lt1"/>
-          </a:fontRef>
-        </p:style>
-        <p:txBody>
-          <a:bodyPr rtlCol="0" anchor="ctr"/>
-          <a:lstStyle/>
-          <a:p>
-            <a:pPr algn="ctr"/>
-          </a:p>
-        </p:txBody>
-      </p:sp>
-      <p:sp>
-        <p:nvSpPr>
-          <p:cNvPr id="9" name="TextBox 8"/>
-          <p:cNvSpPr txBox="1"/>
-          <p:nvPr/>
-        </p:nvSpPr>
-        <p:spPr>
-          <a:xfrm>
-            <a:off x="5303520" y="2103120"/>
-            <a:ext cx="5882335" cy="365760"/>
-          </a:xfrm>
-          <a:prstGeom prst="rect">
-            <a:avLst/>
-          </a:prstGeom>
-          <a:noFill/>
-        </p:spPr>
-        <p:txBody>
-          <a:bodyPr wrap="square" anchor="t" lIns="0" rIns="0" tIns="0" bIns="0">
-            <a:spAutoFit/>
-          </a:bodyPr>
-          <a:lstStyle/>
-          <a:p>
-            <a:pPr algn="l">
-              <a:lnSpc>
-                <a:spcPct val="100000"/>
-              </a:lnSpc>
-              <a:spcAft>
-                <a:spcPts val="0"/>
-              </a:spcAft>
-            </a:pPr>
-            <a:r>
-              <a:rPr sz="1350" b="1" i="0">
-                <a:solidFill>
-                  <a:srgbClr val="0E6B6B"/>
-                </a:solidFill>
-                <a:latin typeface="Helvetica Neue"/>
-              </a:rPr>
-              <a:t>Entity names the agent guessed and SAP rejected</a:t>
-            </a:r>
-          </a:p>
-        </p:txBody>
-      </p:sp>
-      <p:sp>
-        <p:nvSpPr>
-          <p:cNvPr id="10" name="TextBox 9"/>
-          <p:cNvSpPr txBox="1"/>
-          <p:nvPr/>
-        </p:nvSpPr>
-        <p:spPr>
-          <a:xfrm>
-            <a:off x="5303520" y="2606040"/>
-            <a:ext cx="5882335" cy="822960"/>
-          </a:xfrm>
-          <a:prstGeom prst="rect">
-            <a:avLst/>
-          </a:prstGeom>
-          <a:noFill/>
-        </p:spPr>
-        <p:txBody>
-          <a:bodyPr wrap="square" anchor="t" lIns="0" rIns="0" tIns="0" bIns="0">
-            <a:spAutoFit/>
-          </a:bodyPr>
-          <a:lstStyle/>
-          <a:p>
-            <a:pPr algn="l">
-              <a:lnSpc>
-                <a:spcPct val="140000"/>
-              </a:lnSpc>
-              <a:spcAft>
-                <a:spcPts val="0"/>
-              </a:spcAft>
-            </a:pPr>
-            <a:r>
-              <a:rPr sz="1700" b="1" i="0">
-                <a:solidFill>
-                  <a:srgbClr val="0B142A"/>
-                </a:solidFill>
-                <a:latin typeface="Courier New"/>
-              </a:rPr>
-              <a:t>A_PaymentTerms</a:t>
-            </a:r>
-          </a:p>
-          <a:p>
-            <a:pPr algn="l">
-              <a:lnSpc>
-                <a:spcPct val="140000"/>
-              </a:lnSpc>
-              <a:spcAft>
-                <a:spcPts val="0"/>
-              </a:spcAft>
-            </a:pPr>
-            <a:r>
-              <a:rPr sz="1700" b="1" i="0">
-                <a:solidFill>
-                  <a:srgbClr val="0B142A"/>
-                </a:solidFill>
-                <a:latin typeface="Courier New"/>
-              </a:rPr>
-              <a:t>A_SupplierRole</a:t>
+              <a:t>The same five tasks, repeated with a frontier model and a strong open source model, same harness, same tools, same logging.</a:t>
             </a:r>
           </a:p>
         </p:txBody>
       </p:sp>
       <p:cxnSp>
         <p:nvCxnSpPr>
-          <p:cNvPr id="11" name="Connector 10"/>
+          <p:cNvPr id="6" name="Connector 5"/>
           <p:cNvCxnSpPr/>
           <p:nvPr/>
         </p:nvCxnSpPr>
         <p:spPr>
           <a:xfrm>
-            <a:off x="5303520" y="3566160"/>
-            <a:ext cx="5882335" cy="0"/>
+            <a:off x="640080" y="2240280"/>
+            <a:ext cx="10911535" cy="0"/>
           </a:xfrm>
           <a:prstGeom prst="line">
             <a:avLst/>
           </a:prstGeom>
-          <a:ln w="12700">
+          <a:ln w="15875">
             <a:solidFill>
-              <a:srgbClr val="C7DAD9"/>
+              <a:srgbClr val="0B142A"/>
             </a:solidFill>
           </a:ln>
           <a:effectLst/>
@@ -8822,14 +9231,218 @@
       </p:cxnSp>
       <p:sp>
         <p:nvSpPr>
+          <p:cNvPr id="7" name="TextBox 6"/>
+          <p:cNvSpPr txBox="1"/>
+          <p:nvPr/>
+        </p:nvSpPr>
+        <p:spPr>
+          <a:xfrm>
+            <a:off x="640080" y="2313432"/>
+            <a:ext cx="3291840" cy="411480"/>
+          </a:xfrm>
+          <a:prstGeom prst="rect">
+            <a:avLst/>
+          </a:prstGeom>
+          <a:noFill/>
+        </p:spPr>
+        <p:txBody>
+          <a:bodyPr wrap="square" anchor="t" lIns="0" rIns="0" tIns="0" bIns="0">
+            <a:spAutoFit/>
+          </a:bodyPr>
+          <a:lstStyle/>
+          <a:p>
+            <a:pPr algn="l">
+              <a:lnSpc>
+                <a:spcPct val="105000"/>
+              </a:lnSpc>
+              <a:spcAft>
+                <a:spcPts val="0"/>
+              </a:spcAft>
+            </a:pPr>
+            <a:r>
+              <a:rPr sz="1200" b="1" i="0">
+                <a:solidFill>
+                  <a:srgbClr val="6B7280"/>
+                </a:solidFill>
+                <a:latin typeface="Helvetica Neue"/>
+              </a:rPr>
+              <a:t>Task</a:t>
+            </a:r>
+          </a:p>
+        </p:txBody>
+      </p:sp>
+      <p:sp>
+        <p:nvSpPr>
+          <p:cNvPr id="8" name="TextBox 7"/>
+          <p:cNvSpPr txBox="1"/>
+          <p:nvPr/>
+        </p:nvSpPr>
+        <p:spPr>
+          <a:xfrm>
+            <a:off x="3931920" y="2313432"/>
+            <a:ext cx="2539898" cy="411480"/>
+          </a:xfrm>
+          <a:prstGeom prst="rect">
+            <a:avLst/>
+          </a:prstGeom>
+          <a:noFill/>
+        </p:spPr>
+        <p:txBody>
+          <a:bodyPr wrap="square" anchor="t" lIns="0" rIns="0" tIns="0" bIns="0">
+            <a:spAutoFit/>
+          </a:bodyPr>
+          <a:lstStyle/>
+          <a:p>
+            <a:pPr algn="ctr">
+              <a:lnSpc>
+                <a:spcPct val="105000"/>
+              </a:lnSpc>
+              <a:spcAft>
+                <a:spcPts val="0"/>
+              </a:spcAft>
+            </a:pPr>
+            <a:r>
+              <a:rPr sz="1200" b="1" i="0">
+                <a:solidFill>
+                  <a:srgbClr val="6B7280"/>
+                </a:solidFill>
+                <a:latin typeface="Helvetica Neue"/>
+              </a:rPr>
+              <a:t>GPT-4o mini (small)</a:t>
+            </a:r>
+          </a:p>
+        </p:txBody>
+      </p:sp>
+      <p:sp>
+        <p:nvSpPr>
+          <p:cNvPr id="9" name="TextBox 8"/>
+          <p:cNvSpPr txBox="1"/>
+          <p:nvPr/>
+        </p:nvSpPr>
+        <p:spPr>
+          <a:xfrm>
+            <a:off x="6471818" y="2313432"/>
+            <a:ext cx="2539898" cy="411480"/>
+          </a:xfrm>
+          <a:prstGeom prst="rect">
+            <a:avLst/>
+          </a:prstGeom>
+          <a:noFill/>
+        </p:spPr>
+        <p:txBody>
+          <a:bodyPr wrap="square" anchor="t" lIns="0" rIns="0" tIns="0" bIns="0">
+            <a:spAutoFit/>
+          </a:bodyPr>
+          <a:lstStyle/>
+          <a:p>
+            <a:pPr algn="ctr">
+              <a:lnSpc>
+                <a:spcPct val="105000"/>
+              </a:lnSpc>
+              <a:spcAft>
+                <a:spcPts val="0"/>
+              </a:spcAft>
+            </a:pPr>
+            <a:r>
+              <a:rPr sz="1200" b="1" i="0">
+                <a:solidFill>
+                  <a:srgbClr val="6B7280"/>
+                </a:solidFill>
+                <a:latin typeface="Helvetica Neue"/>
+              </a:rPr>
+              <a:t>GPT-4.1 (frontier)</a:t>
+            </a:r>
+          </a:p>
+        </p:txBody>
+      </p:sp>
+      <p:sp>
+        <p:nvSpPr>
+          <p:cNvPr id="10" name="TextBox 9"/>
+          <p:cNvSpPr txBox="1"/>
+          <p:nvPr/>
+        </p:nvSpPr>
+        <p:spPr>
+          <a:xfrm>
+            <a:off x="9011716" y="2313432"/>
+            <a:ext cx="2539898" cy="411480"/>
+          </a:xfrm>
+          <a:prstGeom prst="rect">
+            <a:avLst/>
+          </a:prstGeom>
+          <a:noFill/>
+        </p:spPr>
+        <p:txBody>
+          <a:bodyPr wrap="square" anchor="t" lIns="0" rIns="0" tIns="0" bIns="0">
+            <a:spAutoFit/>
+          </a:bodyPr>
+          <a:lstStyle/>
+          <a:p>
+            <a:pPr algn="ctr">
+              <a:lnSpc>
+                <a:spcPct val="105000"/>
+              </a:lnSpc>
+              <a:spcAft>
+                <a:spcPts val="0"/>
+              </a:spcAft>
+            </a:pPr>
+            <a:r>
+              <a:rPr sz="1200" b="1" i="0">
+                <a:solidFill>
+                  <a:srgbClr val="6B7280"/>
+                </a:solidFill>
+                <a:latin typeface="Helvetica Neue"/>
+              </a:rPr>
+              <a:t>Llama 4 Maverick (open)</a:t>
+            </a:r>
+          </a:p>
+        </p:txBody>
+      </p:sp>
+      <p:cxnSp>
+        <p:nvCxnSpPr>
+          <p:cNvPr id="11" name="Connector 10"/>
+          <p:cNvCxnSpPr/>
+          <p:nvPr/>
+        </p:nvCxnSpPr>
+        <p:spPr>
+          <a:xfrm>
+            <a:off x="640080" y="2788920"/>
+            <a:ext cx="10911535" cy="0"/>
+          </a:xfrm>
+          <a:prstGeom prst="line">
+            <a:avLst/>
+          </a:prstGeom>
+          <a:ln w="12700">
+            <a:solidFill>
+              <a:srgbClr val="0B142A"/>
+            </a:solidFill>
+          </a:ln>
+          <a:effectLst/>
+        </p:spPr>
+        <p:style>
+          <a:lnRef idx="2">
+            <a:schemeClr val="accent1"/>
+          </a:lnRef>
+          <a:fillRef idx="0">
+            <a:schemeClr val="accent1"/>
+          </a:fillRef>
+          <a:effectRef idx="1">
+            <a:schemeClr val="accent1"/>
+          </a:effectRef>
+          <a:fontRef idx="minor">
+            <a:schemeClr val="tx1"/>
+          </a:fontRef>
+        </p:style>
+      </p:cxnSp>
+      <p:sp>
+        <p:nvSpPr>
           <p:cNvPr id="12" name="TextBox 11"/>
           <p:cNvSpPr txBox="1"/>
           <p:nvPr/>
         </p:nvSpPr>
         <p:spPr>
           <a:xfrm>
-            <a:off x="5303520" y="3749039"/>
-            <a:ext cx="5882335" cy="1463040"/>
+            <a:off x="640080" y="2898648"/>
+            <a:ext cx="3291840" cy="365760"/>
           </a:xfrm>
           <a:prstGeom prst="rect">
             <a:avLst/>
@@ -8844,7 +9457,7 @@
           <a:p>
             <a:pPr algn="l">
               <a:lnSpc>
-                <a:spcPct val="128000"/>
+                <a:spcPct val="100000"/>
               </a:lnSpc>
               <a:spcAft>
                 <a:spcPts val="0"/>
@@ -8857,7 +9470,7 @@
                 </a:solidFill>
                 <a:latin typeface="Helvetica Neue"/>
               </a:rPr>
-              <a:t>It also used a filter function the OData v2 gateway rejects outright, and recovered each time by reading the error and adjusting course. The stumbles are not model stupidity, they are the cost of a fifty year old data model exposed through an API that assumes the caller already knows it.</a:t>
+              <a:t>Find a supplier</a:t>
             </a:r>
           </a:p>
         </p:txBody>
@@ -8865,6 +9478,1072 @@
       <p:sp>
         <p:nvSpPr>
           <p:cNvPr id="13" name="TextBox 12"/>
+          <p:cNvSpPr txBox="1"/>
+          <p:nvPr/>
+        </p:nvSpPr>
+        <p:spPr>
+          <a:xfrm>
+            <a:off x="3931920" y="2898648"/>
+            <a:ext cx="2539898" cy="365760"/>
+          </a:xfrm>
+          <a:prstGeom prst="rect">
+            <a:avLst/>
+          </a:prstGeom>
+          <a:noFill/>
+        </p:spPr>
+        <p:txBody>
+          <a:bodyPr wrap="square" anchor="t" lIns="0" rIns="0" tIns="0" bIns="0">
+            <a:spAutoFit/>
+          </a:bodyPr>
+          <a:lstStyle/>
+          <a:p>
+            <a:pPr algn="ctr">
+              <a:lnSpc>
+                <a:spcPct val="100000"/>
+              </a:lnSpc>
+              <a:spcAft>
+                <a:spcPts val="0"/>
+              </a:spcAft>
+            </a:pPr>
+            <a:r>
+              <a:rPr sz="1300" b="0" i="0">
+                <a:solidFill>
+                  <a:srgbClr val="0B142A"/>
+                </a:solidFill>
+                <a:latin typeface="Helvetica Neue"/>
+              </a:rPr>
+              <a:t>success, 11 calls</a:t>
+            </a:r>
+          </a:p>
+        </p:txBody>
+      </p:sp>
+      <p:sp>
+        <p:nvSpPr>
+          <p:cNvPr id="14" name="TextBox 13"/>
+          <p:cNvSpPr txBox="1"/>
+          <p:nvPr/>
+        </p:nvSpPr>
+        <p:spPr>
+          <a:xfrm>
+            <a:off x="6471818" y="2898648"/>
+            <a:ext cx="2539898" cy="365760"/>
+          </a:xfrm>
+          <a:prstGeom prst="rect">
+            <a:avLst/>
+          </a:prstGeom>
+          <a:noFill/>
+        </p:spPr>
+        <p:txBody>
+          <a:bodyPr wrap="square" anchor="t" lIns="0" rIns="0" tIns="0" bIns="0">
+            <a:spAutoFit/>
+          </a:bodyPr>
+          <a:lstStyle/>
+          <a:p>
+            <a:pPr algn="ctr">
+              <a:lnSpc>
+                <a:spcPct val="100000"/>
+              </a:lnSpc>
+              <a:spcAft>
+                <a:spcPts val="0"/>
+              </a:spcAft>
+            </a:pPr>
+            <a:r>
+              <a:rPr sz="1300" b="0" i="0">
+                <a:solidFill>
+                  <a:srgbClr val="0B142A"/>
+                </a:solidFill>
+                <a:latin typeface="Helvetica Neue"/>
+              </a:rPr>
+              <a:t>success, 1 call</a:t>
+            </a:r>
+          </a:p>
+        </p:txBody>
+      </p:sp>
+      <p:sp>
+        <p:nvSpPr>
+          <p:cNvPr id="15" name="TextBox 14"/>
+          <p:cNvSpPr txBox="1"/>
+          <p:nvPr/>
+        </p:nvSpPr>
+        <p:spPr>
+          <a:xfrm>
+            <a:off x="9011716" y="2898648"/>
+            <a:ext cx="2539898" cy="365760"/>
+          </a:xfrm>
+          <a:prstGeom prst="rect">
+            <a:avLst/>
+          </a:prstGeom>
+          <a:noFill/>
+        </p:spPr>
+        <p:txBody>
+          <a:bodyPr wrap="square" anchor="t" lIns="0" rIns="0" tIns="0" bIns="0">
+            <a:spAutoFit/>
+          </a:bodyPr>
+          <a:lstStyle/>
+          <a:p>
+            <a:pPr algn="ctr">
+              <a:lnSpc>
+                <a:spcPct val="100000"/>
+              </a:lnSpc>
+              <a:spcAft>
+                <a:spcPts val="0"/>
+              </a:spcAft>
+            </a:pPr>
+            <a:r>
+              <a:rPr sz="1300" b="0" i="0">
+                <a:solidFill>
+                  <a:srgbClr val="9C3B2E"/>
+                </a:solidFill>
+                <a:latin typeface="Helvetica Neue"/>
+              </a:rPr>
+              <a:t>gave up, 3 calls</a:t>
+            </a:r>
+          </a:p>
+        </p:txBody>
+      </p:sp>
+      <p:cxnSp>
+        <p:nvCxnSpPr>
+          <p:cNvPr id="16" name="Connector 15"/>
+          <p:cNvCxnSpPr/>
+          <p:nvPr/>
+        </p:nvCxnSpPr>
+        <p:spPr>
+          <a:xfrm>
+            <a:off x="640080" y="3227832"/>
+            <a:ext cx="10911535" cy="0"/>
+          </a:xfrm>
+          <a:prstGeom prst="line">
+            <a:avLst/>
+          </a:prstGeom>
+          <a:ln w="7620">
+            <a:solidFill>
+              <a:srgbClr val="DDE1E6"/>
+            </a:solidFill>
+          </a:ln>
+          <a:effectLst/>
+        </p:spPr>
+        <p:style>
+          <a:lnRef idx="2">
+            <a:schemeClr val="accent1"/>
+          </a:lnRef>
+          <a:fillRef idx="0">
+            <a:schemeClr val="accent1"/>
+          </a:fillRef>
+          <a:effectRef idx="1">
+            <a:schemeClr val="accent1"/>
+          </a:effectRef>
+          <a:fontRef idx="minor">
+            <a:schemeClr val="tx1"/>
+          </a:fontRef>
+        </p:style>
+      </p:cxnSp>
+      <p:sp>
+        <p:nvSpPr>
+          <p:cNvPr id="17" name="TextBox 16"/>
+          <p:cNvSpPr txBox="1"/>
+          <p:nvPr/>
+        </p:nvSpPr>
+        <p:spPr>
+          <a:xfrm>
+            <a:off x="640080" y="3337560"/>
+            <a:ext cx="3291840" cy="365760"/>
+          </a:xfrm>
+          <a:prstGeom prst="rect">
+            <a:avLst/>
+          </a:prstGeom>
+          <a:noFill/>
+        </p:spPr>
+        <p:txBody>
+          <a:bodyPr wrap="square" anchor="t" lIns="0" rIns="0" tIns="0" bIns="0">
+            <a:spAutoFit/>
+          </a:bodyPr>
+          <a:lstStyle/>
+          <a:p>
+            <a:pPr algn="l">
+              <a:lnSpc>
+                <a:spcPct val="100000"/>
+              </a:lnSpc>
+              <a:spcAft>
+                <a:spcPts val="0"/>
+              </a:spcAft>
+            </a:pPr>
+            <a:r>
+              <a:rPr sz="1300" b="0" i="0">
+                <a:solidFill>
+                  <a:srgbClr val="0B142A"/>
+                </a:solidFill>
+                <a:latin typeface="Helvetica Neue"/>
+              </a:rPr>
+              <a:t>List purchase orders</a:t>
+            </a:r>
+          </a:p>
+        </p:txBody>
+      </p:sp>
+      <p:sp>
+        <p:nvSpPr>
+          <p:cNvPr id="18" name="TextBox 17"/>
+          <p:cNvSpPr txBox="1"/>
+          <p:nvPr/>
+        </p:nvSpPr>
+        <p:spPr>
+          <a:xfrm>
+            <a:off x="3931920" y="3337560"/>
+            <a:ext cx="2539898" cy="365760"/>
+          </a:xfrm>
+          <a:prstGeom prst="rect">
+            <a:avLst/>
+          </a:prstGeom>
+          <a:noFill/>
+        </p:spPr>
+        <p:txBody>
+          <a:bodyPr wrap="square" anchor="t" lIns="0" rIns="0" tIns="0" bIns="0">
+            <a:spAutoFit/>
+          </a:bodyPr>
+          <a:lstStyle/>
+          <a:p>
+            <a:pPr algn="ctr">
+              <a:lnSpc>
+                <a:spcPct val="100000"/>
+              </a:lnSpc>
+              <a:spcAft>
+                <a:spcPts val="0"/>
+              </a:spcAft>
+            </a:pPr>
+            <a:r>
+              <a:rPr sz="1300" b="0" i="0">
+                <a:solidFill>
+                  <a:srgbClr val="0B142A"/>
+                </a:solidFill>
+                <a:latin typeface="Helvetica Neue"/>
+              </a:rPr>
+              <a:t>success</a:t>
+            </a:r>
+          </a:p>
+        </p:txBody>
+      </p:sp>
+      <p:sp>
+        <p:nvSpPr>
+          <p:cNvPr id="19" name="TextBox 18"/>
+          <p:cNvSpPr txBox="1"/>
+          <p:nvPr/>
+        </p:nvSpPr>
+        <p:spPr>
+          <a:xfrm>
+            <a:off x="6471818" y="3337560"/>
+            <a:ext cx="2539898" cy="365760"/>
+          </a:xfrm>
+          <a:prstGeom prst="rect">
+            <a:avLst/>
+          </a:prstGeom>
+          <a:noFill/>
+        </p:spPr>
+        <p:txBody>
+          <a:bodyPr wrap="square" anchor="t" lIns="0" rIns="0" tIns="0" bIns="0">
+            <a:spAutoFit/>
+          </a:bodyPr>
+          <a:lstStyle/>
+          <a:p>
+            <a:pPr algn="ctr">
+              <a:lnSpc>
+                <a:spcPct val="100000"/>
+              </a:lnSpc>
+              <a:spcAft>
+                <a:spcPts val="0"/>
+              </a:spcAft>
+            </a:pPr>
+            <a:r>
+              <a:rPr sz="1300" b="0" i="0">
+                <a:solidFill>
+                  <a:srgbClr val="0B142A"/>
+                </a:solidFill>
+                <a:latin typeface="Helvetica Neue"/>
+              </a:rPr>
+              <a:t>success</a:t>
+            </a:r>
+          </a:p>
+        </p:txBody>
+      </p:sp>
+      <p:sp>
+        <p:nvSpPr>
+          <p:cNvPr id="20" name="TextBox 19"/>
+          <p:cNvSpPr txBox="1"/>
+          <p:nvPr/>
+        </p:nvSpPr>
+        <p:spPr>
+          <a:xfrm>
+            <a:off x="9011716" y="3337560"/>
+            <a:ext cx="2539898" cy="365760"/>
+          </a:xfrm>
+          <a:prstGeom prst="rect">
+            <a:avLst/>
+          </a:prstGeom>
+          <a:noFill/>
+        </p:spPr>
+        <p:txBody>
+          <a:bodyPr wrap="square" anchor="t" lIns="0" rIns="0" tIns="0" bIns="0">
+            <a:spAutoFit/>
+          </a:bodyPr>
+          <a:lstStyle/>
+          <a:p>
+            <a:pPr algn="ctr">
+              <a:lnSpc>
+                <a:spcPct val="100000"/>
+              </a:lnSpc>
+              <a:spcAft>
+                <a:spcPts val="0"/>
+              </a:spcAft>
+            </a:pPr>
+            <a:r>
+              <a:rPr sz="1300" b="0" i="0">
+                <a:solidFill>
+                  <a:srgbClr val="0B142A"/>
+                </a:solidFill>
+                <a:latin typeface="Helvetica Neue"/>
+              </a:rPr>
+              <a:t>success</a:t>
+            </a:r>
+          </a:p>
+        </p:txBody>
+      </p:sp>
+      <p:cxnSp>
+        <p:nvCxnSpPr>
+          <p:cNvPr id="21" name="Connector 20"/>
+          <p:cNvCxnSpPr/>
+          <p:nvPr/>
+        </p:nvCxnSpPr>
+        <p:spPr>
+          <a:xfrm>
+            <a:off x="640080" y="3666744"/>
+            <a:ext cx="10911535" cy="0"/>
+          </a:xfrm>
+          <a:prstGeom prst="line">
+            <a:avLst/>
+          </a:prstGeom>
+          <a:ln w="7620">
+            <a:solidFill>
+              <a:srgbClr val="DDE1E6"/>
+            </a:solidFill>
+          </a:ln>
+          <a:effectLst/>
+        </p:spPr>
+        <p:style>
+          <a:lnRef idx="2">
+            <a:schemeClr val="accent1"/>
+          </a:lnRef>
+          <a:fillRef idx="0">
+            <a:schemeClr val="accent1"/>
+          </a:fillRef>
+          <a:effectRef idx="1">
+            <a:schemeClr val="accent1"/>
+          </a:effectRef>
+          <a:fontRef idx="minor">
+            <a:schemeClr val="tx1"/>
+          </a:fontRef>
+        </p:style>
+      </p:cxnSp>
+      <p:sp>
+        <p:nvSpPr>
+          <p:cNvPr id="22" name="TextBox 21"/>
+          <p:cNvSpPr txBox="1"/>
+          <p:nvPr/>
+        </p:nvSpPr>
+        <p:spPr>
+          <a:xfrm>
+            <a:off x="640080" y="3776472"/>
+            <a:ext cx="3291840" cy="365760"/>
+          </a:xfrm>
+          <a:prstGeom prst="rect">
+            <a:avLst/>
+          </a:prstGeom>
+          <a:noFill/>
+        </p:spPr>
+        <p:txBody>
+          <a:bodyPr wrap="square" anchor="t" lIns="0" rIns="0" tIns="0" bIns="0">
+            <a:spAutoFit/>
+          </a:bodyPr>
+          <a:lstStyle/>
+          <a:p>
+            <a:pPr algn="l">
+              <a:lnSpc>
+                <a:spcPct val="100000"/>
+              </a:lnSpc>
+              <a:spcAft>
+                <a:spcPts val="0"/>
+              </a:spcAft>
+            </a:pPr>
+            <a:r>
+              <a:rPr sz="1300" b="0" i="0">
+                <a:solidFill>
+                  <a:srgbClr val="0B142A"/>
+                </a:solidFill>
+                <a:latin typeface="Helvetica Neue"/>
+              </a:rPr>
+              <a:t>Create a purchase order</a:t>
+            </a:r>
+          </a:p>
+        </p:txBody>
+      </p:sp>
+      <p:sp>
+        <p:nvSpPr>
+          <p:cNvPr id="23" name="TextBox 22"/>
+          <p:cNvSpPr txBox="1"/>
+          <p:nvPr/>
+        </p:nvSpPr>
+        <p:spPr>
+          <a:xfrm>
+            <a:off x="3931920" y="3776472"/>
+            <a:ext cx="2539898" cy="365760"/>
+          </a:xfrm>
+          <a:prstGeom prst="rect">
+            <a:avLst/>
+          </a:prstGeom>
+          <a:noFill/>
+        </p:spPr>
+        <p:txBody>
+          <a:bodyPr wrap="square" anchor="t" lIns="0" rIns="0" tIns="0" bIns="0">
+            <a:spAutoFit/>
+          </a:bodyPr>
+          <a:lstStyle/>
+          <a:p>
+            <a:pPr algn="ctr">
+              <a:lnSpc>
+                <a:spcPct val="100000"/>
+              </a:lnSpc>
+              <a:spcAft>
+                <a:spcPts val="0"/>
+              </a:spcAft>
+            </a:pPr>
+            <a:r>
+              <a:rPr sz="1300" b="0" i="0">
+                <a:solidFill>
+                  <a:srgbClr val="9C3B2E"/>
+                </a:solidFill>
+                <a:latin typeface="Helvetica Neue"/>
+              </a:rPr>
+              <a:t>blocked, 405</a:t>
+            </a:r>
+          </a:p>
+        </p:txBody>
+      </p:sp>
+      <p:sp>
+        <p:nvSpPr>
+          <p:cNvPr id="24" name="TextBox 23"/>
+          <p:cNvSpPr txBox="1"/>
+          <p:nvPr/>
+        </p:nvSpPr>
+        <p:spPr>
+          <a:xfrm>
+            <a:off x="6471818" y="3776472"/>
+            <a:ext cx="2539898" cy="365760"/>
+          </a:xfrm>
+          <a:prstGeom prst="rect">
+            <a:avLst/>
+          </a:prstGeom>
+          <a:noFill/>
+        </p:spPr>
+        <p:txBody>
+          <a:bodyPr wrap="square" anchor="t" lIns="0" rIns="0" tIns="0" bIns="0">
+            <a:spAutoFit/>
+          </a:bodyPr>
+          <a:lstStyle/>
+          <a:p>
+            <a:pPr algn="ctr">
+              <a:lnSpc>
+                <a:spcPct val="100000"/>
+              </a:lnSpc>
+              <a:spcAft>
+                <a:spcPts val="0"/>
+              </a:spcAft>
+            </a:pPr>
+            <a:r>
+              <a:rPr sz="1300" b="0" i="0">
+                <a:solidFill>
+                  <a:srgbClr val="9C3B2E"/>
+                </a:solidFill>
+                <a:latin typeface="Helvetica Neue"/>
+              </a:rPr>
+              <a:t>blocked, 405</a:t>
+            </a:r>
+          </a:p>
+        </p:txBody>
+      </p:sp>
+      <p:sp>
+        <p:nvSpPr>
+          <p:cNvPr id="25" name="TextBox 24"/>
+          <p:cNvSpPr txBox="1"/>
+          <p:nvPr/>
+        </p:nvSpPr>
+        <p:spPr>
+          <a:xfrm>
+            <a:off x="9011716" y="3776472"/>
+            <a:ext cx="2539898" cy="365760"/>
+          </a:xfrm>
+          <a:prstGeom prst="rect">
+            <a:avLst/>
+          </a:prstGeom>
+          <a:noFill/>
+        </p:spPr>
+        <p:txBody>
+          <a:bodyPr wrap="square" anchor="t" lIns="0" rIns="0" tIns="0" bIns="0">
+            <a:spAutoFit/>
+          </a:bodyPr>
+          <a:lstStyle/>
+          <a:p>
+            <a:pPr algn="ctr">
+              <a:lnSpc>
+                <a:spcPct val="100000"/>
+              </a:lnSpc>
+              <a:spcAft>
+                <a:spcPts val="0"/>
+              </a:spcAft>
+            </a:pPr>
+            <a:r>
+              <a:rPr sz="1300" b="0" i="0">
+                <a:solidFill>
+                  <a:srgbClr val="9C3B2E"/>
+                </a:solidFill>
+                <a:latin typeface="Helvetica Neue"/>
+              </a:rPr>
+              <a:t>blocked, 405</a:t>
+            </a:r>
+          </a:p>
+        </p:txBody>
+      </p:sp>
+      <p:cxnSp>
+        <p:nvCxnSpPr>
+          <p:cNvPr id="26" name="Connector 25"/>
+          <p:cNvCxnSpPr/>
+          <p:nvPr/>
+        </p:nvCxnSpPr>
+        <p:spPr>
+          <a:xfrm>
+            <a:off x="640080" y="4105656"/>
+            <a:ext cx="10911535" cy="0"/>
+          </a:xfrm>
+          <a:prstGeom prst="line">
+            <a:avLst/>
+          </a:prstGeom>
+          <a:ln w="7620">
+            <a:solidFill>
+              <a:srgbClr val="DDE1E6"/>
+            </a:solidFill>
+          </a:ln>
+          <a:effectLst/>
+        </p:spPr>
+        <p:style>
+          <a:lnRef idx="2">
+            <a:schemeClr val="accent1"/>
+          </a:lnRef>
+          <a:fillRef idx="0">
+            <a:schemeClr val="accent1"/>
+          </a:fillRef>
+          <a:effectRef idx="1">
+            <a:schemeClr val="accent1"/>
+          </a:effectRef>
+          <a:fontRef idx="minor">
+            <a:schemeClr val="tx1"/>
+          </a:fontRef>
+        </p:style>
+      </p:cxnSp>
+      <p:sp>
+        <p:nvSpPr>
+          <p:cNvPr id="27" name="TextBox 26"/>
+          <p:cNvSpPr txBox="1"/>
+          <p:nvPr/>
+        </p:nvSpPr>
+        <p:spPr>
+          <a:xfrm>
+            <a:off x="640080" y="4215384"/>
+            <a:ext cx="3291840" cy="365760"/>
+          </a:xfrm>
+          <a:prstGeom prst="rect">
+            <a:avLst/>
+          </a:prstGeom>
+          <a:noFill/>
+        </p:spPr>
+        <p:txBody>
+          <a:bodyPr wrap="square" anchor="t" lIns="0" rIns="0" tIns="0" bIns="0">
+            <a:spAutoFit/>
+          </a:bodyPr>
+          <a:lstStyle/>
+          <a:p>
+            <a:pPr algn="l">
+              <a:lnSpc>
+                <a:spcPct val="100000"/>
+              </a:lnSpc>
+              <a:spcAft>
+                <a:spcPts val="0"/>
+              </a:spcAft>
+            </a:pPr>
+            <a:r>
+              <a:rPr sz="1300" b="0" i="0">
+                <a:solidFill>
+                  <a:srgbClr val="0B142A"/>
+                </a:solidFill>
+                <a:latin typeface="Helvetica Neue"/>
+              </a:rPr>
+              <a:t>Summarize invoices</a:t>
+            </a:r>
+          </a:p>
+        </p:txBody>
+      </p:sp>
+      <p:sp>
+        <p:nvSpPr>
+          <p:cNvPr id="28" name="TextBox 27"/>
+          <p:cNvSpPr txBox="1"/>
+          <p:nvPr/>
+        </p:nvSpPr>
+        <p:spPr>
+          <a:xfrm>
+            <a:off x="3931920" y="4215384"/>
+            <a:ext cx="2539898" cy="365760"/>
+          </a:xfrm>
+          <a:prstGeom prst="rect">
+            <a:avLst/>
+          </a:prstGeom>
+          <a:noFill/>
+        </p:spPr>
+        <p:txBody>
+          <a:bodyPr wrap="square" anchor="t" lIns="0" rIns="0" tIns="0" bIns="0">
+            <a:spAutoFit/>
+          </a:bodyPr>
+          <a:lstStyle/>
+          <a:p>
+            <a:pPr algn="ctr">
+              <a:lnSpc>
+                <a:spcPct val="100000"/>
+              </a:lnSpc>
+              <a:spcAft>
+                <a:spcPts val="0"/>
+              </a:spcAft>
+            </a:pPr>
+            <a:r>
+              <a:rPr sz="1300" b="0" i="0">
+                <a:solidFill>
+                  <a:srgbClr val="0B142A"/>
+                </a:solidFill>
+                <a:latin typeface="Helvetica Neue"/>
+              </a:rPr>
+              <a:t>success</a:t>
+            </a:r>
+          </a:p>
+        </p:txBody>
+      </p:sp>
+      <p:sp>
+        <p:nvSpPr>
+          <p:cNvPr id="29" name="TextBox 28"/>
+          <p:cNvSpPr txBox="1"/>
+          <p:nvPr/>
+        </p:nvSpPr>
+        <p:spPr>
+          <a:xfrm>
+            <a:off x="6471818" y="4215384"/>
+            <a:ext cx="2539898" cy="365760"/>
+          </a:xfrm>
+          <a:prstGeom prst="rect">
+            <a:avLst/>
+          </a:prstGeom>
+          <a:noFill/>
+        </p:spPr>
+        <p:txBody>
+          <a:bodyPr wrap="square" anchor="t" lIns="0" rIns="0" tIns="0" bIns="0">
+            <a:spAutoFit/>
+          </a:bodyPr>
+          <a:lstStyle/>
+          <a:p>
+            <a:pPr algn="ctr">
+              <a:lnSpc>
+                <a:spcPct val="100000"/>
+              </a:lnSpc>
+              <a:spcAft>
+                <a:spcPts val="0"/>
+              </a:spcAft>
+            </a:pPr>
+            <a:r>
+              <a:rPr sz="1300" b="0" i="0">
+                <a:solidFill>
+                  <a:srgbClr val="0B142A"/>
+                </a:solidFill>
+                <a:latin typeface="Helvetica Neue"/>
+              </a:rPr>
+              <a:t>success</a:t>
+            </a:r>
+          </a:p>
+        </p:txBody>
+      </p:sp>
+      <p:sp>
+        <p:nvSpPr>
+          <p:cNvPr id="30" name="TextBox 29"/>
+          <p:cNvSpPr txBox="1"/>
+          <p:nvPr/>
+        </p:nvSpPr>
+        <p:spPr>
+          <a:xfrm>
+            <a:off x="9011716" y="4215384"/>
+            <a:ext cx="2539898" cy="365760"/>
+          </a:xfrm>
+          <a:prstGeom prst="rect">
+            <a:avLst/>
+          </a:prstGeom>
+          <a:noFill/>
+        </p:spPr>
+        <p:txBody>
+          <a:bodyPr wrap="square" anchor="t" lIns="0" rIns="0" tIns="0" bIns="0">
+            <a:spAutoFit/>
+          </a:bodyPr>
+          <a:lstStyle/>
+          <a:p>
+            <a:pPr algn="ctr">
+              <a:lnSpc>
+                <a:spcPct val="100000"/>
+              </a:lnSpc>
+              <a:spcAft>
+                <a:spcPts val="0"/>
+              </a:spcAft>
+            </a:pPr>
+            <a:r>
+              <a:rPr sz="1300" b="0" i="0">
+                <a:solidFill>
+                  <a:srgbClr val="0B142A"/>
+                </a:solidFill>
+                <a:latin typeface="Helvetica Neue"/>
+              </a:rPr>
+              <a:t>success</a:t>
+            </a:r>
+          </a:p>
+        </p:txBody>
+      </p:sp>
+      <p:cxnSp>
+        <p:nvCxnSpPr>
+          <p:cNvPr id="31" name="Connector 30"/>
+          <p:cNvCxnSpPr/>
+          <p:nvPr/>
+        </p:nvCxnSpPr>
+        <p:spPr>
+          <a:xfrm>
+            <a:off x="640080" y="4544568"/>
+            <a:ext cx="10911535" cy="0"/>
+          </a:xfrm>
+          <a:prstGeom prst="line">
+            <a:avLst/>
+          </a:prstGeom>
+          <a:ln w="7620">
+            <a:solidFill>
+              <a:srgbClr val="DDE1E6"/>
+            </a:solidFill>
+          </a:ln>
+          <a:effectLst/>
+        </p:spPr>
+        <p:style>
+          <a:lnRef idx="2">
+            <a:schemeClr val="accent1"/>
+          </a:lnRef>
+          <a:fillRef idx="0">
+            <a:schemeClr val="accent1"/>
+          </a:fillRef>
+          <a:effectRef idx="1">
+            <a:schemeClr val="accent1"/>
+          </a:effectRef>
+          <a:fontRef idx="minor">
+            <a:schemeClr val="tx1"/>
+          </a:fontRef>
+        </p:style>
+      </p:cxnSp>
+      <p:sp>
+        <p:nvSpPr>
+          <p:cNvPr id="32" name="TextBox 31"/>
+          <p:cNvSpPr txBox="1"/>
+          <p:nvPr/>
+        </p:nvSpPr>
+        <p:spPr>
+          <a:xfrm>
+            <a:off x="640080" y="4654296"/>
+            <a:ext cx="3291840" cy="365760"/>
+          </a:xfrm>
+          <a:prstGeom prst="rect">
+            <a:avLst/>
+          </a:prstGeom>
+          <a:noFill/>
+        </p:spPr>
+        <p:txBody>
+          <a:bodyPr wrap="square" anchor="t" lIns="0" rIns="0" tIns="0" bIns="0">
+            <a:spAutoFit/>
+          </a:bodyPr>
+          <a:lstStyle/>
+          <a:p>
+            <a:pPr algn="l">
+              <a:lnSpc>
+                <a:spcPct val="100000"/>
+              </a:lnSpc>
+              <a:spcAft>
+                <a:spcPts val="0"/>
+              </a:spcAft>
+            </a:pPr>
+            <a:r>
+              <a:rPr sz="1300" b="0" i="0">
+                <a:solidFill>
+                  <a:srgbClr val="0B142A"/>
+                </a:solidFill>
+                <a:latin typeface="Helvetica Neue"/>
+              </a:rPr>
+              <a:t>Product base unit and type</a:t>
+            </a:r>
+          </a:p>
+        </p:txBody>
+      </p:sp>
+      <p:sp>
+        <p:nvSpPr>
+          <p:cNvPr id="33" name="TextBox 32"/>
+          <p:cNvSpPr txBox="1"/>
+          <p:nvPr/>
+        </p:nvSpPr>
+        <p:spPr>
+          <a:xfrm>
+            <a:off x="3931920" y="4654296"/>
+            <a:ext cx="2539898" cy="365760"/>
+          </a:xfrm>
+          <a:prstGeom prst="rect">
+            <a:avLst/>
+          </a:prstGeom>
+          <a:noFill/>
+        </p:spPr>
+        <p:txBody>
+          <a:bodyPr wrap="square" anchor="t" lIns="0" rIns="0" tIns="0" bIns="0">
+            <a:spAutoFit/>
+          </a:bodyPr>
+          <a:lstStyle/>
+          <a:p>
+            <a:pPr algn="ctr">
+              <a:lnSpc>
+                <a:spcPct val="100000"/>
+              </a:lnSpc>
+              <a:spcAft>
+                <a:spcPts val="0"/>
+              </a:spcAft>
+            </a:pPr>
+            <a:r>
+              <a:rPr sz="1300" b="0" i="0">
+                <a:solidFill>
+                  <a:srgbClr val="0B142A"/>
+                </a:solidFill>
+                <a:latin typeface="Helvetica Neue"/>
+              </a:rPr>
+              <a:t>success</a:t>
+            </a:r>
+          </a:p>
+        </p:txBody>
+      </p:sp>
+      <p:sp>
+        <p:nvSpPr>
+          <p:cNvPr id="34" name="TextBox 33"/>
+          <p:cNvSpPr txBox="1"/>
+          <p:nvPr/>
+        </p:nvSpPr>
+        <p:spPr>
+          <a:xfrm>
+            <a:off x="6471818" y="4654296"/>
+            <a:ext cx="2539898" cy="365760"/>
+          </a:xfrm>
+          <a:prstGeom prst="rect">
+            <a:avLst/>
+          </a:prstGeom>
+          <a:noFill/>
+        </p:spPr>
+        <p:txBody>
+          <a:bodyPr wrap="square" anchor="t" lIns="0" rIns="0" tIns="0" bIns="0">
+            <a:spAutoFit/>
+          </a:bodyPr>
+          <a:lstStyle/>
+          <a:p>
+            <a:pPr algn="ctr">
+              <a:lnSpc>
+                <a:spcPct val="100000"/>
+              </a:lnSpc>
+              <a:spcAft>
+                <a:spcPts val="0"/>
+              </a:spcAft>
+            </a:pPr>
+            <a:r>
+              <a:rPr sz="1300" b="0" i="0">
+                <a:solidFill>
+                  <a:srgbClr val="0B142A"/>
+                </a:solidFill>
+                <a:latin typeface="Helvetica Neue"/>
+              </a:rPr>
+              <a:t>success</a:t>
+            </a:r>
+          </a:p>
+        </p:txBody>
+      </p:sp>
+      <p:sp>
+        <p:nvSpPr>
+          <p:cNvPr id="35" name="TextBox 34"/>
+          <p:cNvSpPr txBox="1"/>
+          <p:nvPr/>
+        </p:nvSpPr>
+        <p:spPr>
+          <a:xfrm>
+            <a:off x="9011716" y="4654296"/>
+            <a:ext cx="2539898" cy="365760"/>
+          </a:xfrm>
+          <a:prstGeom prst="rect">
+            <a:avLst/>
+          </a:prstGeom>
+          <a:noFill/>
+        </p:spPr>
+        <p:txBody>
+          <a:bodyPr wrap="square" anchor="t" lIns="0" rIns="0" tIns="0" bIns="0">
+            <a:spAutoFit/>
+          </a:bodyPr>
+          <a:lstStyle/>
+          <a:p>
+            <a:pPr algn="ctr">
+              <a:lnSpc>
+                <a:spcPct val="100000"/>
+              </a:lnSpc>
+              <a:spcAft>
+                <a:spcPts val="0"/>
+              </a:spcAft>
+            </a:pPr>
+            <a:r>
+              <a:rPr sz="1300" b="0" i="0">
+                <a:solidFill>
+                  <a:srgbClr val="0B142A"/>
+                </a:solidFill>
+                <a:latin typeface="Helvetica Neue"/>
+              </a:rPr>
+              <a:t>success</a:t>
+            </a:r>
+          </a:p>
+        </p:txBody>
+      </p:sp>
+      <p:cxnSp>
+        <p:nvCxnSpPr>
+          <p:cNvPr id="36" name="Connector 35"/>
+          <p:cNvCxnSpPr/>
+          <p:nvPr/>
+        </p:nvCxnSpPr>
+        <p:spPr>
+          <a:xfrm>
+            <a:off x="640080" y="4983480"/>
+            <a:ext cx="10911535" cy="0"/>
+          </a:xfrm>
+          <a:prstGeom prst="line">
+            <a:avLst/>
+          </a:prstGeom>
+          <a:ln w="7620">
+            <a:solidFill>
+              <a:srgbClr val="DDE1E6"/>
+            </a:solidFill>
+          </a:ln>
+          <a:effectLst/>
+        </p:spPr>
+        <p:style>
+          <a:lnRef idx="2">
+            <a:schemeClr val="accent1"/>
+          </a:lnRef>
+          <a:fillRef idx="0">
+            <a:schemeClr val="accent1"/>
+          </a:fillRef>
+          <a:effectRef idx="1">
+            <a:schemeClr val="accent1"/>
+          </a:effectRef>
+          <a:fontRef idx="minor">
+            <a:schemeClr val="tx1"/>
+          </a:fontRef>
+        </p:style>
+      </p:cxnSp>
+      <p:sp>
+        <p:nvSpPr>
+          <p:cNvPr id="37" name="Rounded Rectangle 36"/>
+          <p:cNvSpPr/>
+          <p:nvPr/>
+        </p:nvSpPr>
+        <p:spPr>
+          <a:xfrm>
+            <a:off x="640080" y="5166360"/>
+            <a:ext cx="10911535" cy="731520"/>
+          </a:xfrm>
+          <a:prstGeom prst="roundRect">
+            <a:avLst>
+              <a:gd name="adj" fmla="val 8000"/>
+            </a:avLst>
+          </a:prstGeom>
+          <a:solidFill>
+            <a:srgbClr val="0B142A"/>
+          </a:solidFill>
+          <a:ln>
+            <a:noFill/>
+          </a:ln>
+          <a:effectLst/>
+        </p:spPr>
+        <p:style>
+          <a:lnRef idx="1">
+            <a:schemeClr val="accent1"/>
+          </a:lnRef>
+          <a:fillRef idx="3">
+            <a:schemeClr val="accent1"/>
+          </a:fillRef>
+          <a:effectRef idx="2">
+            <a:schemeClr val="accent1"/>
+          </a:effectRef>
+          <a:fontRef idx="minor">
+            <a:schemeClr val="lt1"/>
+          </a:fontRef>
+        </p:style>
+        <p:txBody>
+          <a:bodyPr rtlCol="0" anchor="ctr"/>
+          <a:lstStyle/>
+          <a:p>
+            <a:pPr algn="ctr"/>
+          </a:p>
+        </p:txBody>
+      </p:sp>
+      <p:sp>
+        <p:nvSpPr>
+          <p:cNvPr id="38" name="TextBox 37"/>
+          <p:cNvSpPr txBox="1"/>
+          <p:nvPr/>
+        </p:nvSpPr>
+        <p:spPr>
+          <a:xfrm>
+            <a:off x="1005840" y="5166360"/>
+            <a:ext cx="10180015" cy="731520"/>
+          </a:xfrm>
+          <a:prstGeom prst="rect">
+            <a:avLst/>
+          </a:prstGeom>
+          <a:noFill/>
+        </p:spPr>
+        <p:txBody>
+          <a:bodyPr wrap="square" anchor="ctr" lIns="0" rIns="0" tIns="0" bIns="0">
+            <a:spAutoFit/>
+          </a:bodyPr>
+          <a:lstStyle/>
+          <a:p>
+            <a:pPr algn="l">
+              <a:lnSpc>
+                <a:spcPct val="125000"/>
+              </a:lnSpc>
+              <a:spcAft>
+                <a:spcPts val="0"/>
+              </a:spcAft>
+            </a:pPr>
+            <a:r>
+              <a:rPr sz="1450" b="0" i="1">
+                <a:solidFill>
+                  <a:srgbClr val="FFFFFF"/>
+                </a:solidFill>
+                <a:latin typeface="Helvetica Neue"/>
+              </a:rPr>
+              <a:t>Model quality buys efficiency, not new capability. No model gets through a platform policy. All three hit the same 405 wall on the write task.</a:t>
+            </a:r>
+          </a:p>
+        </p:txBody>
+      </p:sp>
+      <p:sp>
+        <p:nvSpPr>
+          <p:cNvPr id="39" name="TextBox 38"/>
           <p:cNvSpPr txBox="1"/>
           <p:nvPr/>
         </p:nvSpPr>
@@ -8906,7 +10585,7 @@
       </p:sp>
       <p:sp>
         <p:nvSpPr>
-          <p:cNvPr id="14" name="TextBox 13"/>
+          <p:cNvPr id="40" name="TextBox 39"/>
           <p:cNvSpPr txBox="1"/>
           <p:nvPr/>
         </p:nvSpPr>
@@ -8941,7 +10620,7 @@
                 </a:solidFill>
                 <a:latin typeface="Helvetica Neue"/>
               </a:rPr>
-              <a:t>06 / 10</a:t>
+              <a:t>06 / 11</a:t>
             </a:r>
           </a:p>
         </p:txBody>
@@ -9009,7 +10688,7 @@
                 </a:solidFill>
                 <a:latin typeface="Helvetica Neue"/>
               </a:rPr>
-              <a:t>FINDING 2</a:t>
+              <a:t>FINDING 1</a:t>
             </a:r>
           </a:p>
         </p:txBody>
@@ -9051,7 +10730,7 @@
                 </a:solidFill>
                 <a:latin typeface="Georgia"/>
               </a:rPr>
-              <a:t>Writing to the enterprise is walled off</a:t>
+              <a:t>Reading works, but discovery is expensive</a:t>
             </a:r>
           </a:p>
         </p:txBody>
@@ -9125,11 +10804,11 @@
             <a:r>
               <a:rPr sz="5200" b="1" i="0">
                 <a:solidFill>
-                  <a:srgbClr val="9C3B2E"/>
+                  <a:srgbClr val="0E6B6B"/>
                 </a:solidFill>
                 <a:latin typeface="Georgia"/>
               </a:rPr>
-              <a:t>405</a:t>
+              <a:t>11</a:t>
             </a:r>
           </a:p>
         </p:txBody>
@@ -9171,7 +10850,7 @@
                 </a:solidFill>
                 <a:latin typeface="Helvetica Neue"/>
               </a:rPr>
-              <a:t>HTTP response to the</a:t>
+              <a:t>API calls to find</a:t>
             </a:r>
           </a:p>
           <a:p>
@@ -9190,7 +10869,7 @@
                 </a:solidFill>
                 <a:latin typeface="Helvetica Neue"/>
               </a:rPr>
-              <a:t>purchase order write attempt</a:t>
+              <a:t>one supplier by name</a:t>
             </a:r>
           </a:p>
         </p:txBody>
@@ -9203,8 +10882,8 @@
         </p:nvSpPr>
         <p:spPr>
           <a:xfrm>
-            <a:off x="640080" y="3703320"/>
-            <a:ext cx="3383280" cy="2286000"/>
+            <a:off x="640080" y="3657600"/>
+            <a:ext cx="3383280" cy="2377440"/>
           </a:xfrm>
           <a:prstGeom prst="rect">
             <a:avLst/>
@@ -9232,7 +10911,7 @@
                 </a:solidFill>
                 <a:latin typeface="Helvetica Neue"/>
               </a:rPr>
-              <a:t>SAP's message was direct, the public sandbox supports GET operations only, and write operations must be tested against a customer's own system.</a:t>
+              <a:t>The agent completed every read task. But the simplest sounding one, find one supplier by name, took 11 calls because the agent had to discover SAP's data model by trial and error.</a:t>
             </a:r>
           </a:p>
         </p:txBody>
@@ -9246,15 +10925,15 @@
         <p:spPr>
           <a:xfrm>
             <a:off x="4937760" y="1828800"/>
-            <a:ext cx="6613855" cy="1417320"/>
+            <a:ext cx="6613855" cy="3566160"/>
           </a:xfrm>
           <a:prstGeom prst="roundRect">
             <a:avLst>
-              <a:gd name="adj" fmla="val 6000"/>
+              <a:gd name="adj" fmla="val 5000"/>
             </a:avLst>
           </a:prstGeom>
           <a:solidFill>
-            <a:srgbClr val="0B142A"/>
+            <a:srgbClr val="E4F0EF"/>
           </a:solidFill>
           <a:ln>
             <a:noFill/>
@@ -9291,36 +10970,36 @@
         </p:nvSpPr>
         <p:spPr>
           <a:xfrm>
-            <a:off x="5303520" y="1993392"/>
-            <a:ext cx="5882335" cy="1097280"/>
-          </a:xfrm>
-          <a:prstGeom prst="rect">
-            <a:avLst/>
-          </a:prstGeom>
-          <a:noFill/>
-        </p:spPr>
-        <p:txBody>
-          <a:bodyPr wrap="square" anchor="ctr" lIns="0" rIns="0" tIns="0" bIns="0">
+            <a:off x="5303520" y="2103120"/>
+            <a:ext cx="5882335" cy="365760"/>
+          </a:xfrm>
+          <a:prstGeom prst="rect">
+            <a:avLst/>
+          </a:prstGeom>
+          <a:noFill/>
+        </p:spPr>
+        <p:txBody>
+          <a:bodyPr wrap="square" anchor="t" lIns="0" rIns="0" tIns="0" bIns="0">
             <a:spAutoFit/>
           </a:bodyPr>
           <a:lstStyle/>
           <a:p>
             <a:pPr algn="l">
               <a:lnSpc>
-                <a:spcPct val="135000"/>
-              </a:lnSpc>
-              <a:spcAft>
-                <a:spcPts val="0"/>
-              </a:spcAft>
-            </a:pPr>
-            <a:r>
-              <a:rPr sz="1500" b="0" i="1">
-                <a:solidFill>
-                  <a:srgbClr val="FFFFFF"/>
-                </a:solidFill>
-                <a:latin typeface="Helvetica Neue"/>
-              </a:rPr>
-              <a:t>“The public sandbox supports GET operations only. Write operations must be tested against a customer's own system.”</a:t>
+                <a:spcPct val="100000"/>
+              </a:lnSpc>
+              <a:spcAft>
+                <a:spcPts val="0"/>
+              </a:spcAft>
+            </a:pPr>
+            <a:r>
+              <a:rPr sz="1350" b="1" i="0">
+                <a:solidFill>
+                  <a:srgbClr val="0E6B6B"/>
+                </a:solidFill>
+                <a:latin typeface="Helvetica Neue"/>
+              </a:rPr>
+              <a:t>Entity names the agent guessed and SAP rejected</a:t>
             </a:r>
           </a:p>
         </p:txBody>
@@ -9333,8 +11012,8 @@
         </p:nvSpPr>
         <p:spPr>
           <a:xfrm>
-            <a:off x="4937760" y="3520440"/>
-            <a:ext cx="6613855" cy="1737360"/>
+            <a:off x="5303520" y="2606040"/>
+            <a:ext cx="5882335" cy="822960"/>
           </a:xfrm>
           <a:prstGeom prst="rect">
             <a:avLst/>
@@ -9349,27 +11028,124 @@
           <a:p>
             <a:pPr algn="l">
               <a:lnSpc>
-                <a:spcPct val="132000"/>
-              </a:lnSpc>
-              <a:spcAft>
-                <a:spcPts val="0"/>
-              </a:spcAft>
-            </a:pPr>
-            <a:r>
-              <a:rPr sz="1400" b="0" i="0">
+                <a:spcPct val="140000"/>
+              </a:lnSpc>
+              <a:spcAft>
+                <a:spcPts val="0"/>
+              </a:spcAft>
+            </a:pPr>
+            <a:r>
+              <a:rPr sz="1700" b="1" i="0">
                 <a:solidFill>
                   <a:srgbClr val="0B142A"/>
                 </a:solidFill>
-                <a:latin typeface="Helvetica Neue"/>
-              </a:rPr>
-              <a:t>The public evaluation surface of the world's largest ERP vendor lets an agent look but not act. Anyone claiming their agent “works with SAP” on the basis of public APIs is describing a read only integration, a distinction buyers should press on.</a:t>
-            </a:r>
-          </a:p>
-        </p:txBody>
-      </p:sp>
-      <p:sp>
-        <p:nvSpPr>
-          <p:cNvPr id="11" name="TextBox 10"/>
+                <a:latin typeface="Courier New"/>
+              </a:rPr>
+              <a:t>A_PaymentTerms</a:t>
+            </a:r>
+          </a:p>
+          <a:p>
+            <a:pPr algn="l">
+              <a:lnSpc>
+                <a:spcPct val="140000"/>
+              </a:lnSpc>
+              <a:spcAft>
+                <a:spcPts val="0"/>
+              </a:spcAft>
+            </a:pPr>
+            <a:r>
+              <a:rPr sz="1700" b="1" i="0">
+                <a:solidFill>
+                  <a:srgbClr val="0B142A"/>
+                </a:solidFill>
+                <a:latin typeface="Courier New"/>
+              </a:rPr>
+              <a:t>A_SupplierRole</a:t>
+            </a:r>
+          </a:p>
+        </p:txBody>
+      </p:sp>
+      <p:cxnSp>
+        <p:nvCxnSpPr>
+          <p:cNvPr id="11" name="Connector 10"/>
+          <p:cNvCxnSpPr/>
+          <p:nvPr/>
+        </p:nvCxnSpPr>
+        <p:spPr>
+          <a:xfrm>
+            <a:off x="5303520" y="3566160"/>
+            <a:ext cx="5882335" cy="0"/>
+          </a:xfrm>
+          <a:prstGeom prst="line">
+            <a:avLst/>
+          </a:prstGeom>
+          <a:ln w="12700">
+            <a:solidFill>
+              <a:srgbClr val="C7DAD9"/>
+            </a:solidFill>
+          </a:ln>
+          <a:effectLst/>
+        </p:spPr>
+        <p:style>
+          <a:lnRef idx="2">
+            <a:schemeClr val="accent1"/>
+          </a:lnRef>
+          <a:fillRef idx="0">
+            <a:schemeClr val="accent1"/>
+          </a:fillRef>
+          <a:effectRef idx="1">
+            <a:schemeClr val="accent1"/>
+          </a:effectRef>
+          <a:fontRef idx="minor">
+            <a:schemeClr val="tx1"/>
+          </a:fontRef>
+        </p:style>
+      </p:cxnSp>
+      <p:sp>
+        <p:nvSpPr>
+          <p:cNvPr id="12" name="TextBox 11"/>
+          <p:cNvSpPr txBox="1"/>
+          <p:nvPr/>
+        </p:nvSpPr>
+        <p:spPr>
+          <a:xfrm>
+            <a:off x="5303520" y="3749039"/>
+            <a:ext cx="5882335" cy="1463040"/>
+          </a:xfrm>
+          <a:prstGeom prst="rect">
+            <a:avLst/>
+          </a:prstGeom>
+          <a:noFill/>
+        </p:spPr>
+        <p:txBody>
+          <a:bodyPr wrap="square" anchor="t" lIns="0" rIns="0" tIns="0" bIns="0">
+            <a:spAutoFit/>
+          </a:bodyPr>
+          <a:lstStyle/>
+          <a:p>
+            <a:pPr algn="l">
+              <a:lnSpc>
+                <a:spcPct val="128000"/>
+              </a:lnSpc>
+              <a:spcAft>
+                <a:spcPts val="0"/>
+              </a:spcAft>
+            </a:pPr>
+            <a:r>
+              <a:rPr sz="1300" b="0" i="0">
+                <a:solidFill>
+                  <a:srgbClr val="0B142A"/>
+                </a:solidFill>
+                <a:latin typeface="Helvetica Neue"/>
+              </a:rPr>
+              <a:t>It also used a filter function the OData v2 gateway rejects outright, and recovered each time by reading the error and adjusting course. The stumbles are not model stupidity, they are the cost of a fifty year old data model exposed through an API that assumes the caller already knows it.</a:t>
+            </a:r>
+          </a:p>
+        </p:txBody>
+      </p:sp>
+      <p:sp>
+        <p:nvSpPr>
+          <p:cNvPr id="13" name="TextBox 12"/>
           <p:cNvSpPr txBox="1"/>
           <p:nvPr/>
         </p:nvSpPr>
@@ -9411,7 +11187,7 @@
       </p:sp>
       <p:sp>
         <p:nvSpPr>
-          <p:cNvPr id="12" name="TextBox 11"/>
+          <p:cNvPr id="14" name="TextBox 13"/>
           <p:cNvSpPr txBox="1"/>
           <p:nvPr/>
         </p:nvSpPr>
@@ -9446,7 +11222,7 @@
                 </a:solidFill>
                 <a:latin typeface="Helvetica Neue"/>
               </a:rPr>
-              <a:t>07 / 10</a:t>
+              <a:t>07 / 11</a:t>
             </a:r>
           </a:p>
         </p:txBody>
@@ -9514,7 +11290,7 @@
                 </a:solidFill>
                 <a:latin typeface="Helvetica Neue"/>
               </a:rPr>
-              <a:t>FINDING 3</a:t>
+              <a:t>FINDING 2</a:t>
             </a:r>
           </a:p>
         </p:txBody>
@@ -9556,7 +11332,7 @@
                 </a:solidFill>
                 <a:latin typeface="Georgia"/>
               </a:rPr>
-              <a:t>Verbosity is a tax on agents</a:t>
+              <a:t>Writing to the enterprise is walled off</a:t>
             </a:r>
           </a:p>
         </p:txBody>
@@ -9628,13 +11404,13 @@
               </a:spcAft>
             </a:pPr>
             <a:r>
-              <a:rPr sz="4800" b="1" i="0">
-                <a:solidFill>
-                  <a:srgbClr val="0E6B6B"/>
+              <a:rPr sz="5200" b="1" i="0">
+                <a:solidFill>
+                  <a:srgbClr val="9C3B2E"/>
                 </a:solidFill>
                 <a:latin typeface="Georgia"/>
               </a:rPr>
-              <a:t>8,000</a:t>
+              <a:t>405</a:t>
             </a:r>
           </a:p>
         </p:txBody>
@@ -9647,7 +11423,7 @@
         </p:nvSpPr>
         <p:spPr>
           <a:xfrm>
-            <a:off x="640080" y="2547019"/>
+            <a:off x="640080" y="2606871"/>
             <a:ext cx="3383280" cy="548640"/>
           </a:xfrm>
           <a:prstGeom prst="rect">
@@ -9676,7 +11452,7 @@
                 </a:solidFill>
                 <a:latin typeface="Helvetica Neue"/>
               </a:rPr>
-              <a:t>token limit overflowed by</a:t>
+              <a:t>HTTP response to the</a:t>
             </a:r>
           </a:p>
           <a:p>
@@ -9695,7 +11471,7 @@
                 </a:solidFill>
                 <a:latin typeface="Helvetica Neue"/>
               </a:rPr>
-              <a:t>a single unfiltered API reply</a:t>
+              <a:t>purchase order write attempt</a:t>
             </a:r>
           </a:p>
         </p:txBody>
@@ -9709,7 +11485,7 @@
         <p:spPr>
           <a:xfrm>
             <a:off x="640080" y="3703320"/>
-            <a:ext cx="3383280" cy="2377440"/>
+            <a:ext cx="3383280" cy="2286000"/>
           </a:xfrm>
           <a:prstGeom prst="rect">
             <a:avLst/>
@@ -9737,27 +11513,29 @@
                 </a:solidFill>
                 <a:latin typeface="Helvetica Neue"/>
               </a:rPr>
-              <a:t>SAP's raw responses are large enough that one unfiltered reply overflowed the free model's request limit and killed the first run outright. The failed log is preserved in the repository.</a:t>
-            </a:r>
-          </a:p>
-        </p:txBody>
-      </p:sp>
-      <p:sp>
-        <p:nvSpPr>
-          <p:cNvPr id="8" name="Rectangle 7"/>
+              <a:t>SAP's message was direct, the public sandbox supports GET operations only, and write operations must be tested against a customer's own system.</a:t>
+            </a:r>
+          </a:p>
+        </p:txBody>
+      </p:sp>
+      <p:sp>
+        <p:nvSpPr>
+          <p:cNvPr id="8" name="Rounded Rectangle 7"/>
           <p:cNvSpPr/>
           <p:nvPr/>
         </p:nvSpPr>
         <p:spPr>
           <a:xfrm>
-            <a:off x="5120640" y="2103120"/>
-            <a:ext cx="6248095" cy="502920"/>
-          </a:xfrm>
-          <a:prstGeom prst="rect">
-            <a:avLst/>
+            <a:off x="4937760" y="1828800"/>
+            <a:ext cx="6613855" cy="1417320"/>
+          </a:xfrm>
+          <a:prstGeom prst="roundRect">
+            <a:avLst>
+              <a:gd name="adj" fmla="val 6000"/>
+            </a:avLst>
           </a:prstGeom>
           <a:solidFill>
-            <a:srgbClr val="9C3B2E"/>
+            <a:srgbClr val="0B142A"/>
           </a:solidFill>
           <a:ln>
             <a:noFill/>
@@ -9794,36 +11572,36 @@
         </p:nvSpPr>
         <p:spPr>
           <a:xfrm>
-            <a:off x="5120640" y="1783080"/>
-            <a:ext cx="6248095" cy="274320"/>
-          </a:xfrm>
-          <a:prstGeom prst="rect">
-            <a:avLst/>
-          </a:prstGeom>
-          <a:noFill/>
-        </p:spPr>
-        <p:txBody>
-          <a:bodyPr wrap="square" anchor="t" lIns="0" rIns="0" tIns="0" bIns="0">
+            <a:off x="5303520" y="1993392"/>
+            <a:ext cx="5882335" cy="1097280"/>
+          </a:xfrm>
+          <a:prstGeom prst="rect">
+            <a:avLst/>
+          </a:prstGeom>
+          <a:noFill/>
+        </p:spPr>
+        <p:txBody>
+          <a:bodyPr wrap="square" anchor="ctr" lIns="0" rIns="0" tIns="0" bIns="0">
             <a:spAutoFit/>
           </a:bodyPr>
           <a:lstStyle/>
           <a:p>
             <a:pPr algn="l">
               <a:lnSpc>
-                <a:spcPct val="100000"/>
-              </a:lnSpc>
-              <a:spcAft>
-                <a:spcPts val="0"/>
-              </a:spcAft>
-            </a:pPr>
-            <a:r>
-              <a:rPr sz="1250" b="0" i="0">
-                <a:solidFill>
-                  <a:srgbClr val="6B7280"/>
-                </a:solidFill>
-                <a:latin typeface="Helvetica Neue"/>
-              </a:rPr>
-              <a:t>Raw SAP response</a:t>
+                <a:spcPct val="135000"/>
+              </a:lnSpc>
+              <a:spcAft>
+                <a:spcPts val="0"/>
+              </a:spcAft>
+            </a:pPr>
+            <a:r>
+              <a:rPr sz="1500" b="0" i="1">
+                <a:solidFill>
+                  <a:srgbClr val="FFFFFF"/>
+                </a:solidFill>
+                <a:latin typeface="Helvetica Neue"/>
+              </a:rPr>
+              <a:t>“The public sandbox supports GET operations only. Write operations must be tested against a customer's own system.”</a:t>
             </a:r>
           </a:p>
         </p:txBody>
@@ -9836,213 +11614,43 @@
         </p:nvSpPr>
         <p:spPr>
           <a:xfrm>
-            <a:off x="5257800" y="2103120"/>
-            <a:ext cx="5973775" cy="502920"/>
-          </a:xfrm>
-          <a:prstGeom prst="rect">
-            <a:avLst/>
-          </a:prstGeom>
-          <a:noFill/>
-        </p:spPr>
-        <p:txBody>
-          <a:bodyPr wrap="square" anchor="ctr" lIns="0" rIns="0" tIns="0" bIns="0">
+            <a:off x="4937760" y="3520440"/>
+            <a:ext cx="6613855" cy="1737360"/>
+          </a:xfrm>
+          <a:prstGeom prst="rect">
+            <a:avLst/>
+          </a:prstGeom>
+          <a:noFill/>
+        </p:spPr>
+        <p:txBody>
+          <a:bodyPr wrap="square" anchor="t" lIns="0" rIns="0" tIns="0" bIns="0">
             <a:spAutoFit/>
           </a:bodyPr>
           <a:lstStyle/>
           <a:p>
             <a:pPr algn="l">
               <a:lnSpc>
-                <a:spcPct val="100000"/>
-              </a:lnSpc>
-              <a:spcAft>
-                <a:spcPts val="0"/>
-              </a:spcAft>
-            </a:pPr>
-            <a:r>
-              <a:rPr sz="1250" b="1" i="0">
-                <a:solidFill>
-                  <a:srgbClr val="FFFFFF"/>
-                </a:solidFill>
-                <a:latin typeface="Helvetica Neue"/>
-              </a:rPr>
-              <a:t>overflows 8,000 token limit</a:t>
-            </a:r>
-          </a:p>
-        </p:txBody>
-      </p:sp>
-      <p:sp>
-        <p:nvSpPr>
-          <p:cNvPr id="11" name="Rectangle 10"/>
-          <p:cNvSpPr/>
-          <p:nvPr/>
-        </p:nvSpPr>
-        <p:spPr>
-          <a:xfrm>
-            <a:off x="5120640" y="3154680"/>
-            <a:ext cx="2194560" cy="502920"/>
-          </a:xfrm>
-          <a:prstGeom prst="rect">
-            <a:avLst/>
-          </a:prstGeom>
-          <a:solidFill>
-            <a:srgbClr val="0E6B6B"/>
-          </a:solidFill>
-          <a:ln>
-            <a:noFill/>
-          </a:ln>
-          <a:effectLst/>
-        </p:spPr>
-        <p:style>
-          <a:lnRef idx="1">
-            <a:schemeClr val="accent1"/>
-          </a:lnRef>
-          <a:fillRef idx="3">
-            <a:schemeClr val="accent1"/>
-          </a:fillRef>
-          <a:effectRef idx="2">
-            <a:schemeClr val="accent1"/>
-          </a:effectRef>
-          <a:fontRef idx="minor">
-            <a:schemeClr val="lt1"/>
-          </a:fontRef>
-        </p:style>
-        <p:txBody>
-          <a:bodyPr rtlCol="0" anchor="ctr"/>
-          <a:lstStyle/>
-          <a:p>
-            <a:pPr algn="ctr"/>
-          </a:p>
-        </p:txBody>
-      </p:sp>
-      <p:sp>
-        <p:nvSpPr>
-          <p:cNvPr id="12" name="TextBox 11"/>
-          <p:cNvSpPr txBox="1"/>
-          <p:nvPr/>
-        </p:nvSpPr>
-        <p:spPr>
-          <a:xfrm>
-            <a:off x="5120640" y="2834640"/>
-            <a:ext cx="6248095" cy="274320"/>
-          </a:xfrm>
-          <a:prstGeom prst="rect">
-            <a:avLst/>
-          </a:prstGeom>
-          <a:noFill/>
-        </p:spPr>
-        <p:txBody>
-          <a:bodyPr wrap="square" anchor="t" lIns="0" rIns="0" tIns="0" bIns="0">
-            <a:spAutoFit/>
-          </a:bodyPr>
-          <a:lstStyle/>
-          <a:p>
-            <a:pPr algn="l">
-              <a:lnSpc>
-                <a:spcPct val="100000"/>
-              </a:lnSpc>
-              <a:spcAft>
-                <a:spcPts val="0"/>
-              </a:spcAft>
-            </a:pPr>
-            <a:r>
-              <a:rPr sz="1250" b="0" i="0">
-                <a:solidFill>
-                  <a:srgbClr val="6B7280"/>
-                </a:solidFill>
-                <a:latin typeface="Helvetica Neue"/>
-              </a:rPr>
-              <a:t>Trimmed response used by the agent</a:t>
-            </a:r>
-          </a:p>
-        </p:txBody>
-      </p:sp>
-      <p:sp>
-        <p:nvSpPr>
-          <p:cNvPr id="13" name="TextBox 12"/>
-          <p:cNvSpPr txBox="1"/>
-          <p:nvPr/>
-        </p:nvSpPr>
-        <p:spPr>
-          <a:xfrm>
-            <a:off x="5257800" y="3154680"/>
-            <a:ext cx="1920240" cy="502920"/>
-          </a:xfrm>
-          <a:prstGeom prst="rect">
-            <a:avLst/>
-          </a:prstGeom>
-          <a:noFill/>
-        </p:spPr>
-        <p:txBody>
-          <a:bodyPr wrap="square" anchor="ctr" lIns="0" rIns="0" tIns="0" bIns="0">
-            <a:spAutoFit/>
-          </a:bodyPr>
-          <a:lstStyle/>
-          <a:p>
-            <a:pPr algn="l">
-              <a:lnSpc>
-                <a:spcPct val="100000"/>
-              </a:lnSpc>
-              <a:spcAft>
-                <a:spcPts val="0"/>
-              </a:spcAft>
-            </a:pPr>
-            <a:r>
-              <a:rPr sz="1250" b="1" i="0">
-                <a:solidFill>
-                  <a:srgbClr val="FFFFFF"/>
-                </a:solidFill>
-                <a:latin typeface="Helvetica Neue"/>
-              </a:rPr>
-              <a:t>fits comfortably</a:t>
-            </a:r>
-          </a:p>
-        </p:txBody>
-      </p:sp>
-      <p:sp>
-        <p:nvSpPr>
-          <p:cNvPr id="14" name="TextBox 13"/>
-          <p:cNvSpPr txBox="1"/>
-          <p:nvPr/>
-        </p:nvSpPr>
-        <p:spPr>
-          <a:xfrm>
-            <a:off x="5120640" y="4160520"/>
-            <a:ext cx="6430975" cy="1463040"/>
-          </a:xfrm>
-          <a:prstGeom prst="rect">
-            <a:avLst/>
-          </a:prstGeom>
-          <a:noFill/>
-        </p:spPr>
-        <p:txBody>
-          <a:bodyPr wrap="square" anchor="t" lIns="0" rIns="0" tIns="0" bIns="0">
-            <a:spAutoFit/>
-          </a:bodyPr>
-          <a:lstStyle/>
-          <a:p>
-            <a:pPr algn="l">
-              <a:lnSpc>
-                <a:spcPct val="130000"/>
-              </a:lnSpc>
-              <a:spcAft>
-                <a:spcPts val="0"/>
-              </a:spcAft>
-            </a:pPr>
-            <a:r>
-              <a:rPr sz="1350" b="0" i="0">
+                <a:spcPct val="132000"/>
+              </a:lnSpc>
+              <a:spcAft>
+                <a:spcPts val="0"/>
+              </a:spcAft>
+            </a:pPr>
+            <a:r>
+              <a:rPr sz="1400" b="0" i="0">
                 <a:solidFill>
                   <a:srgbClr val="0B142A"/>
                 </a:solidFill>
                 <a:latin typeface="Helvetica Neue"/>
               </a:rPr>
-              <a:t>Enterprise APIs were designed for programs that extract one field and move on. Agents read everything, so response weight becomes a real cost and a real failure mode.</a:t>
-            </a:r>
-          </a:p>
-        </p:txBody>
-      </p:sp>
-      <p:sp>
-        <p:nvSpPr>
-          <p:cNvPr id="15" name="TextBox 14"/>
+              <a:t>The public evaluation surface of the world's largest ERP vendor lets an agent look but not act. Anyone claiming their agent “works with SAP” on the basis of public APIs is describing a read only integration, a distinction buyers should press on.</a:t>
+            </a:r>
+          </a:p>
+        </p:txBody>
+      </p:sp>
+      <p:sp>
+        <p:nvSpPr>
+          <p:cNvPr id="11" name="TextBox 10"/>
           <p:cNvSpPr txBox="1"/>
           <p:nvPr/>
         </p:nvSpPr>
@@ -10084,7 +11692,7 @@
       </p:sp>
       <p:sp>
         <p:nvSpPr>
-          <p:cNvPr id="16" name="TextBox 15"/>
+          <p:cNvPr id="12" name="TextBox 11"/>
           <p:cNvSpPr txBox="1"/>
           <p:nvPr/>
         </p:nvSpPr>
@@ -10119,7 +11727,7 @@
                 </a:solidFill>
                 <a:latin typeface="Helvetica Neue"/>
               </a:rPr>
-              <a:t>08 / 10</a:t>
+              <a:t>08 / 11</a:t>
             </a:r>
           </a:p>
         </p:txBody>
@@ -10187,7 +11795,7 @@
                 </a:solidFill>
                 <a:latin typeface="Helvetica Neue"/>
               </a:rPr>
-              <a:t>FINDING 4</a:t>
+              <a:t>FINDING 3</a:t>
             </a:r>
           </a:p>
         </p:txBody>
@@ -10229,7 +11837,7 @@
                 </a:solidFill>
                 <a:latin typeface="Georgia"/>
               </a:rPr>
-              <a:t>Error messages are the agent's documentation</a:t>
+              <a:t>Verbosity is a tax on agents</a:t>
             </a:r>
           </a:p>
         </p:txBody>
@@ -10279,7 +11887,7 @@
         <p:spPr>
           <a:xfrm>
             <a:off x="640080" y="1828800"/>
-            <a:ext cx="10881360" cy="640080"/>
+            <a:ext cx="3383280" cy="685800"/>
           </a:xfrm>
           <a:prstGeom prst="rect">
             <a:avLst/>
@@ -10294,6 +11902,109 @@
           <a:p>
             <a:pPr algn="l">
               <a:lnSpc>
+                <a:spcPct val="100000"/>
+              </a:lnSpc>
+              <a:spcAft>
+                <a:spcPts val="0"/>
+              </a:spcAft>
+            </a:pPr>
+            <a:r>
+              <a:rPr sz="4800" b="1" i="0">
+                <a:solidFill>
+                  <a:srgbClr val="0E6B6B"/>
+                </a:solidFill>
+                <a:latin typeface="Georgia"/>
+              </a:rPr>
+              <a:t>8,000</a:t>
+            </a:r>
+          </a:p>
+        </p:txBody>
+      </p:sp>
+      <p:sp>
+        <p:nvSpPr>
+          <p:cNvPr id="6" name="TextBox 5"/>
+          <p:cNvSpPr txBox="1"/>
+          <p:nvPr/>
+        </p:nvSpPr>
+        <p:spPr>
+          <a:xfrm>
+            <a:off x="640080" y="2547019"/>
+            <a:ext cx="3383280" cy="548640"/>
+          </a:xfrm>
+          <a:prstGeom prst="rect">
+            <a:avLst/>
+          </a:prstGeom>
+          <a:noFill/>
+        </p:spPr>
+        <p:txBody>
+          <a:bodyPr wrap="square" anchor="t" lIns="0" rIns="0" tIns="0" bIns="0">
+            <a:spAutoFit/>
+          </a:bodyPr>
+          <a:lstStyle/>
+          <a:p>
+            <a:pPr algn="l">
+              <a:lnSpc>
+                <a:spcPct val="115000"/>
+              </a:lnSpc>
+              <a:spcAft>
+                <a:spcPts val="0"/>
+              </a:spcAft>
+            </a:pPr>
+            <a:r>
+              <a:rPr sz="1250" b="0" i="0">
+                <a:solidFill>
+                  <a:srgbClr val="6B7280"/>
+                </a:solidFill>
+                <a:latin typeface="Helvetica Neue"/>
+              </a:rPr>
+              <a:t>token limit overflowed by</a:t>
+            </a:r>
+          </a:p>
+          <a:p>
+            <a:pPr algn="l">
+              <a:lnSpc>
+                <a:spcPct val="115000"/>
+              </a:lnSpc>
+              <a:spcAft>
+                <a:spcPts val="0"/>
+              </a:spcAft>
+            </a:pPr>
+            <a:r>
+              <a:rPr sz="1250" b="0" i="0">
+                <a:solidFill>
+                  <a:srgbClr val="6B7280"/>
+                </a:solidFill>
+                <a:latin typeface="Helvetica Neue"/>
+              </a:rPr>
+              <a:t>a single unfiltered API reply</a:t>
+            </a:r>
+          </a:p>
+        </p:txBody>
+      </p:sp>
+      <p:sp>
+        <p:nvSpPr>
+          <p:cNvPr id="7" name="TextBox 6"/>
+          <p:cNvSpPr txBox="1"/>
+          <p:nvPr/>
+        </p:nvSpPr>
+        <p:spPr>
+          <a:xfrm>
+            <a:off x="640080" y="3703320"/>
+            <a:ext cx="3383280" cy="2377440"/>
+          </a:xfrm>
+          <a:prstGeom prst="rect">
+            <a:avLst/>
+          </a:prstGeom>
+          <a:noFill/>
+        </p:spPr>
+        <p:txBody>
+          <a:bodyPr wrap="square" anchor="t" lIns="0" rIns="0" tIns="0" bIns="0">
+            <a:spAutoFit/>
+          </a:bodyPr>
+          <a:lstStyle/>
+          <a:p>
+            <a:pPr algn="l">
+              <a:lnSpc>
                 <a:spcPct val="130000"/>
               </a:lnSpc>
               <a:spcAft>
@@ -10301,35 +12012,33 @@
               </a:spcAft>
             </a:pPr>
             <a:r>
-              <a:rPr sz="1700" b="0" i="0">
+              <a:rPr sz="1450" b="0" i="0">
                 <a:solidFill>
                   <a:srgbClr val="0B142A"/>
                 </a:solidFill>
                 <a:latin typeface="Helvetica Neue"/>
               </a:rPr>
-              <a:t>The agent never saw SAP documentation, only error responses.</a:t>
-            </a:r>
-          </a:p>
-        </p:txBody>
-      </p:sp>
-      <p:sp>
-        <p:nvSpPr>
-          <p:cNvPr id="6" name="Rounded Rectangle 5"/>
+              <a:t>SAP's raw responses are large enough that one unfiltered reply overflowed the free model's request limit and killed the first run outright. The failed log is preserved in the repository.</a:t>
+            </a:r>
+          </a:p>
+        </p:txBody>
+      </p:sp>
+      <p:sp>
+        <p:nvSpPr>
+          <p:cNvPr id="8" name="Rectangle 7"/>
           <p:cNvSpPr/>
           <p:nvPr/>
         </p:nvSpPr>
         <p:spPr>
           <a:xfrm>
-            <a:off x="640080" y="2651760"/>
-            <a:ext cx="5120640" cy="2651760"/>
-          </a:xfrm>
-          <a:prstGeom prst="roundRect">
-            <a:avLst>
-              <a:gd name="adj" fmla="val 5000"/>
-            </a:avLst>
+            <a:off x="5120640" y="2103120"/>
+            <a:ext cx="6248095" cy="502920"/>
+          </a:xfrm>
+          <a:prstGeom prst="rect">
+            <a:avLst/>
           </a:prstGeom>
           <a:solidFill>
-            <a:srgbClr val="E4F0EF"/>
+            <a:srgbClr val="9C3B2E"/>
           </a:solidFill>
           <a:ln>
             <a:noFill/>
@@ -10360,14 +12069,14 @@
       </p:sp>
       <p:sp>
         <p:nvSpPr>
-          <p:cNvPr id="7" name="TextBox 6"/>
-          <p:cNvSpPr txBox="1"/>
-          <p:nvPr/>
-        </p:nvSpPr>
-        <p:spPr>
-          <a:xfrm>
-            <a:off x="960120" y="2907792"/>
-            <a:ext cx="4480560" cy="320040"/>
+          <p:cNvPr id="9" name="TextBox 8"/>
+          <p:cNvSpPr txBox="1"/>
+          <p:nvPr/>
+        </p:nvSpPr>
+        <p:spPr>
+          <a:xfrm>
+            <a:off x="5120640" y="1783080"/>
+            <a:ext cx="6248095" cy="274320"/>
           </a:xfrm>
           <a:prstGeom prst="rect">
             <a:avLst/>
@@ -10389,124 +12098,78 @@
               </a:spcAft>
             </a:pPr>
             <a:r>
-              <a:rPr sz="1300" b="1" i="0">
-                <a:solidFill>
-                  <a:srgbClr val="0E6B6B"/>
-                </a:solidFill>
-                <a:latin typeface="Helvetica Neue"/>
-              </a:rPr>
-              <a:t>Specific error</a:t>
-            </a:r>
-          </a:p>
-        </p:txBody>
-      </p:sp>
-      <p:sp>
-        <p:nvSpPr>
-          <p:cNvPr id="8" name="TextBox 7"/>
-          <p:cNvSpPr txBox="1"/>
-          <p:nvPr/>
-        </p:nvSpPr>
-        <p:spPr>
-          <a:xfrm>
-            <a:off x="960120" y="3273552"/>
-            <a:ext cx="4480560" cy="777240"/>
-          </a:xfrm>
-          <a:prstGeom prst="rect">
-            <a:avLst/>
-          </a:prstGeom>
-          <a:noFill/>
-        </p:spPr>
-        <p:txBody>
-          <a:bodyPr wrap="square" anchor="t" lIns="0" rIns="0" tIns="0" bIns="0">
+              <a:rPr sz="1250" b="0" i="0">
+                <a:solidFill>
+                  <a:srgbClr val="6B7280"/>
+                </a:solidFill>
+                <a:latin typeface="Helvetica Neue"/>
+              </a:rPr>
+              <a:t>Raw SAP response</a:t>
+            </a:r>
+          </a:p>
+        </p:txBody>
+      </p:sp>
+      <p:sp>
+        <p:nvSpPr>
+          <p:cNvPr id="10" name="TextBox 9"/>
+          <p:cNvSpPr txBox="1"/>
+          <p:nvPr/>
+        </p:nvSpPr>
+        <p:spPr>
+          <a:xfrm>
+            <a:off x="5257800" y="2103120"/>
+            <a:ext cx="5973775" cy="502920"/>
+          </a:xfrm>
+          <a:prstGeom prst="rect">
+            <a:avLst/>
+          </a:prstGeom>
+          <a:noFill/>
+        </p:spPr>
+        <p:txBody>
+          <a:bodyPr wrap="square" anchor="ctr" lIns="0" rIns="0" tIns="0" bIns="0">
             <a:spAutoFit/>
           </a:bodyPr>
           <a:lstStyle/>
           <a:p>
             <a:pPr algn="l">
               <a:lnSpc>
-                <a:spcPct val="130000"/>
-              </a:lnSpc>
-              <a:spcAft>
-                <a:spcPts val="0"/>
-              </a:spcAft>
-            </a:pPr>
-            <a:r>
-              <a:rPr sz="1350" b="0" i="1">
-                <a:solidFill>
-                  <a:srgbClr val="0B142A"/>
-                </a:solidFill>
-                <a:latin typeface="Helvetica Neue"/>
-              </a:rPr>
-              <a:t>“Property contains not found in type A_BusinessPartnerType”</a:t>
-            </a:r>
-          </a:p>
-        </p:txBody>
-      </p:sp>
-      <p:sp>
-        <p:nvSpPr>
-          <p:cNvPr id="9" name="TextBox 8"/>
-          <p:cNvSpPr txBox="1"/>
-          <p:nvPr/>
-        </p:nvSpPr>
-        <p:spPr>
-          <a:xfrm>
-            <a:off x="960120" y="4251960"/>
-            <a:ext cx="4480560" cy="822960"/>
-          </a:xfrm>
-          <a:prstGeom prst="rect">
-            <a:avLst/>
-          </a:prstGeom>
-          <a:noFill/>
-        </p:spPr>
-        <p:txBody>
-          <a:bodyPr wrap="square" anchor="t" lIns="0" rIns="0" tIns="0" bIns="0">
-            <a:spAutoFit/>
-          </a:bodyPr>
-          <a:lstStyle/>
-          <a:p>
-            <a:pPr algn="l">
-              <a:lnSpc>
-                <a:spcPct val="130000"/>
-              </a:lnSpc>
-              <a:spcAft>
-                <a:spcPts val="0"/>
-              </a:spcAft>
-            </a:pPr>
-            <a:r>
-              <a:rPr sz="1400" b="1" i="0">
-                <a:solidFill>
-                  <a:srgbClr val="0B142A"/>
-                </a:solidFill>
-                <a:latin typeface="Helvetica Neue"/>
-              </a:rPr>
-              <a:t>Result: the agent corrected course in one turn</a:t>
-            </a:r>
-          </a:p>
-        </p:txBody>
-      </p:sp>
-      <p:sp>
-        <p:nvSpPr>
-          <p:cNvPr id="10" name="Rounded Rectangle 9"/>
+                <a:spcPct val="100000"/>
+              </a:lnSpc>
+              <a:spcAft>
+                <a:spcPts val="0"/>
+              </a:spcAft>
+            </a:pPr>
+            <a:r>
+              <a:rPr sz="1250" b="1" i="0">
+                <a:solidFill>
+                  <a:srgbClr val="FFFFFF"/>
+                </a:solidFill>
+                <a:latin typeface="Helvetica Neue"/>
+              </a:rPr>
+              <a:t>overflows 8,000 token limit</a:t>
+            </a:r>
+          </a:p>
+        </p:txBody>
+      </p:sp>
+      <p:sp>
+        <p:nvSpPr>
+          <p:cNvPr id="11" name="Rectangle 10"/>
           <p:cNvSpPr/>
           <p:nvPr/>
         </p:nvSpPr>
         <p:spPr>
           <a:xfrm>
-            <a:off x="6400800" y="2651760"/>
-            <a:ext cx="5120640" cy="2651760"/>
-          </a:xfrm>
-          <a:prstGeom prst="roundRect">
-            <a:avLst>
-              <a:gd name="adj" fmla="val 5000"/>
-            </a:avLst>
+            <a:off x="5120640" y="3154680"/>
+            <a:ext cx="2194560" cy="502920"/>
+          </a:xfrm>
+          <a:prstGeom prst="rect">
+            <a:avLst/>
           </a:prstGeom>
           <a:solidFill>
-            <a:srgbClr val="FFFFFF"/>
+            <a:srgbClr val="0E6B6B"/>
           </a:solidFill>
-          <a:ln w="12700">
-            <a:solidFill>
-              <a:srgbClr val="DDE1E6"/>
-            </a:solidFill>
+          <a:ln>
+            <a:noFill/>
           </a:ln>
           <a:effectLst/>
         </p:spPr>
@@ -10534,14 +12197,14 @@
       </p:sp>
       <p:sp>
         <p:nvSpPr>
-          <p:cNvPr id="11" name="TextBox 10"/>
-          <p:cNvSpPr txBox="1"/>
-          <p:nvPr/>
-        </p:nvSpPr>
-        <p:spPr>
-          <a:xfrm>
-            <a:off x="6720840" y="2907792"/>
-            <a:ext cx="4480560" cy="320040"/>
+          <p:cNvPr id="12" name="TextBox 11"/>
+          <p:cNvSpPr txBox="1"/>
+          <p:nvPr/>
+        </p:nvSpPr>
+        <p:spPr>
+          <a:xfrm>
+            <a:off x="5120640" y="2834640"/>
+            <a:ext cx="6248095" cy="274320"/>
           </a:xfrm>
           <a:prstGeom prst="rect">
             <a:avLst/>
@@ -10563,41 +12226,83 @@
               </a:spcAft>
             </a:pPr>
             <a:r>
-              <a:rPr sz="1300" b="1" i="0">
-                <a:solidFill>
-                  <a:srgbClr val="9C3B2E"/>
-                </a:solidFill>
-                <a:latin typeface="Helvetica Neue"/>
-              </a:rPr>
-              <a:t>Vague error</a:t>
-            </a:r>
-          </a:p>
-        </p:txBody>
-      </p:sp>
-      <p:sp>
-        <p:nvSpPr>
-          <p:cNvPr id="12" name="TextBox 11"/>
-          <p:cNvSpPr txBox="1"/>
-          <p:nvPr/>
-        </p:nvSpPr>
-        <p:spPr>
-          <a:xfrm>
-            <a:off x="6720840" y="3273552"/>
-            <a:ext cx="4480560" cy="777240"/>
-          </a:xfrm>
-          <a:prstGeom prst="rect">
-            <a:avLst/>
-          </a:prstGeom>
-          <a:noFill/>
-        </p:spPr>
-        <p:txBody>
-          <a:bodyPr wrap="square" anchor="t" lIns="0" rIns="0" tIns="0" bIns="0">
+              <a:rPr sz="1250" b="0" i="0">
+                <a:solidFill>
+                  <a:srgbClr val="6B7280"/>
+                </a:solidFill>
+                <a:latin typeface="Helvetica Neue"/>
+              </a:rPr>
+              <a:t>Trimmed response used by the agent</a:t>
+            </a:r>
+          </a:p>
+        </p:txBody>
+      </p:sp>
+      <p:sp>
+        <p:nvSpPr>
+          <p:cNvPr id="13" name="TextBox 12"/>
+          <p:cNvSpPr txBox="1"/>
+          <p:nvPr/>
+        </p:nvSpPr>
+        <p:spPr>
+          <a:xfrm>
+            <a:off x="5257800" y="3154680"/>
+            <a:ext cx="1920240" cy="502920"/>
+          </a:xfrm>
+          <a:prstGeom prst="rect">
+            <a:avLst/>
+          </a:prstGeom>
+          <a:noFill/>
+        </p:spPr>
+        <p:txBody>
+          <a:bodyPr wrap="square" anchor="ctr" lIns="0" rIns="0" tIns="0" bIns="0">
             <a:spAutoFit/>
           </a:bodyPr>
           <a:lstStyle/>
           <a:p>
             <a:pPr algn="l">
               <a:lnSpc>
+                <a:spcPct val="100000"/>
+              </a:lnSpc>
+              <a:spcAft>
+                <a:spcPts val="0"/>
+              </a:spcAft>
+            </a:pPr>
+            <a:r>
+              <a:rPr sz="1250" b="1" i="0">
+                <a:solidFill>
+                  <a:srgbClr val="FFFFFF"/>
+                </a:solidFill>
+                <a:latin typeface="Helvetica Neue"/>
+              </a:rPr>
+              <a:t>fits comfortably</a:t>
+            </a:r>
+          </a:p>
+        </p:txBody>
+      </p:sp>
+      <p:sp>
+        <p:nvSpPr>
+          <p:cNvPr id="14" name="TextBox 13"/>
+          <p:cNvSpPr txBox="1"/>
+          <p:nvPr/>
+        </p:nvSpPr>
+        <p:spPr>
+          <a:xfrm>
+            <a:off x="5120640" y="4160520"/>
+            <a:ext cx="6430975" cy="1463040"/>
+          </a:xfrm>
+          <a:prstGeom prst="rect">
+            <a:avLst/>
+          </a:prstGeom>
+          <a:noFill/>
+        </p:spPr>
+        <p:txBody>
+          <a:bodyPr wrap="square" anchor="t" lIns="0" rIns="0" tIns="0" bIns="0">
+            <a:spAutoFit/>
+          </a:bodyPr>
+          <a:lstStyle/>
+          <a:p>
+            <a:pPr algn="l">
+              <a:lnSpc>
                 <a:spcPct val="130000"/>
               </a:lnSpc>
               <a:spcAft>
@@ -10605,97 +12310,13 @@
               </a:spcAft>
             </a:pPr>
             <a:r>
-              <a:rPr sz="1350" b="0" i="1">
+              <a:rPr sz="1350" b="0" i="0">
                 <a:solidFill>
                   <a:srgbClr val="0B142A"/>
                 </a:solidFill>
                 <a:latin typeface="Helvetica Neue"/>
               </a:rPr>
-              <a:t>Generic not found or rejected responses with no field level detail</a:t>
-            </a:r>
-          </a:p>
-        </p:txBody>
-      </p:sp>
-      <p:sp>
-        <p:nvSpPr>
-          <p:cNvPr id="13" name="TextBox 12"/>
-          <p:cNvSpPr txBox="1"/>
-          <p:nvPr/>
-        </p:nvSpPr>
-        <p:spPr>
-          <a:xfrm>
-            <a:off x="6720840" y="4251960"/>
-            <a:ext cx="4480560" cy="822960"/>
-          </a:xfrm>
-          <a:prstGeom prst="rect">
-            <a:avLst/>
-          </a:prstGeom>
-          <a:noFill/>
-        </p:spPr>
-        <p:txBody>
-          <a:bodyPr wrap="square" anchor="t" lIns="0" rIns="0" tIns="0" bIns="0">
-            <a:spAutoFit/>
-          </a:bodyPr>
-          <a:lstStyle/>
-          <a:p>
-            <a:pPr algn="l">
-              <a:lnSpc>
-                <a:spcPct val="130000"/>
-              </a:lnSpc>
-              <a:spcAft>
-                <a:spcPts val="0"/>
-              </a:spcAft>
-            </a:pPr>
-            <a:r>
-              <a:rPr sz="1400" b="1" i="0">
-                <a:solidFill>
-                  <a:srgbClr val="0B142A"/>
-                </a:solidFill>
-                <a:latin typeface="Helvetica Neue"/>
-              </a:rPr>
-              <a:t>Result: repeated failing guesses</a:t>
-            </a:r>
-          </a:p>
-        </p:txBody>
-      </p:sp>
-      <p:sp>
-        <p:nvSpPr>
-          <p:cNvPr id="14" name="TextBox 13"/>
-          <p:cNvSpPr txBox="1"/>
-          <p:nvPr/>
-        </p:nvSpPr>
-        <p:spPr>
-          <a:xfrm>
-            <a:off x="640080" y="5623560"/>
-            <a:ext cx="10881360" cy="640080"/>
-          </a:xfrm>
-          <a:prstGeom prst="rect">
-            <a:avLst/>
-          </a:prstGeom>
-          <a:noFill/>
-        </p:spPr>
-        <p:txBody>
-          <a:bodyPr wrap="square" anchor="t" lIns="0" rIns="0" tIns="0" bIns="0">
-            <a:spAutoFit/>
-          </a:bodyPr>
-          <a:lstStyle/>
-          <a:p>
-            <a:pPr algn="l">
-              <a:lnSpc>
-                <a:spcPct val="130000"/>
-              </a:lnSpc>
-              <a:spcAft>
-                <a:spcPts val="0"/>
-              </a:spcAft>
-            </a:pPr>
-            <a:r>
-              <a:rPr sz="1400" b="0" i="1">
-                <a:solidFill>
-                  <a:srgbClr val="6B7280"/>
-                </a:solidFill>
-                <a:latin typeface="Helvetica Neue"/>
-              </a:rPr>
-              <a:t>For API owners preparing for agent traffic, error message quality is no longer a developer nicety, it is the interface.</a:t>
+              <a:t>Enterprise APIs were designed for programs that extract one field and move on. Agents read everything, so response weight becomes a real cost and a real failure mode.</a:t>
             </a:r>
           </a:p>
         </p:txBody>
@@ -10779,7 +12400,7 @@
                 </a:solidFill>
                 <a:latin typeface="Helvetica Neue"/>
               </a:rPr>
-              <a:t>09 / 10</a:t>
+              <a:t>09 / 11</a:t>
             </a:r>
           </a:p>
         </p:txBody>

</xml_diff>